<commit_message>
feat: pivot v2 — remove travas privadas, add juiz, new logo, SEO & domain setup
- Remove all 4 restriction rules from private bets (free/open)
- Add judge (juiz) role to private bets with pending activation flow
- Fix ambiguous FK join on topic_participants
- Update branding: new Zafe logo (icon + full), PWA icons, favicon
- Configure domain www.zafe.app.br, fix sitemap/robots URLs
- Optimize SEO metadata, JSON-LD, canonical URLs
- Remove deprecated financeiro module
- Organize SQL scripts into folder

Co-Authored-By: Claude Opus 4.6 <noreply@anthropic.com>
</commit_message>
<xml_diff>
--- a/apresentacao_zafe.pptx
+++ b/apresentacao_zafe.pptx
@@ -5,21 +5,22 @@
     <p:sldMasterId id="2147483648" r:id="rId1"/>
   </p:sldMasterIdLst>
   <p:notesMasterIdLst>
-    <p:notesMasterId r:id="rId14"/>
+    <p:notesMasterId r:id="rId15"/>
   </p:notesMasterIdLst>
   <p:sldIdLst>
     <p:sldId id="256" r:id="rId2"/>
-    <p:sldId id="257" r:id="rId3"/>
-    <p:sldId id="258" r:id="rId4"/>
-    <p:sldId id="259" r:id="rId5"/>
-    <p:sldId id="260" r:id="rId6"/>
-    <p:sldId id="261" r:id="rId7"/>
-    <p:sldId id="262" r:id="rId8"/>
-    <p:sldId id="263" r:id="rId9"/>
-    <p:sldId id="264" r:id="rId10"/>
-    <p:sldId id="265" r:id="rId11"/>
-    <p:sldId id="266" r:id="rId12"/>
-    <p:sldId id="267" r:id="rId13"/>
+    <p:sldId id="271" r:id="rId3"/>
+    <p:sldId id="272" r:id="rId4"/>
+    <p:sldId id="276" r:id="rId5"/>
+    <p:sldId id="270" r:id="rId6"/>
+    <p:sldId id="269" r:id="rId7"/>
+    <p:sldId id="268" r:id="rId8"/>
+    <p:sldId id="262" r:id="rId9"/>
+    <p:sldId id="263" r:id="rId10"/>
+    <p:sldId id="275" r:id="rId11"/>
+    <p:sldId id="265" r:id="rId12"/>
+    <p:sldId id="266" r:id="rId13"/>
+    <p:sldId id="273" r:id="rId14"/>
   </p:sldIdLst>
   <p:sldSz cx="12192000" cy="6858000"/>
   <p:notesSz cx="6858000" cy="9144000"/>
@@ -307,7 +308,108 @@
           <a:lstStyle/>
           <a:p>
             <a:r>
-              <a:t>Zafe: liga de previsões (não é aposta, não é cassino). Três pilares: Econômico, Liga, Privadas. Moeda virtual: Zafes. Prêmios reais via PIX no concurso. Apresentação: Luc Sapoznik e Lorenzo Fragali.</a:t>
+              <a:rPr dirty="0" err="1"/>
+              <a:t>Zafe</a:t>
+            </a:r>
+            <a:r>
+              <a:rPr dirty="0"/>
+              <a:t>: </a:t>
+            </a:r>
+            <a:r>
+              <a:rPr dirty="0" err="1"/>
+              <a:t>liga</a:t>
+            </a:r>
+            <a:r>
+              <a:rPr dirty="0"/>
+              <a:t> de </a:t>
+            </a:r>
+            <a:r>
+              <a:rPr dirty="0" err="1"/>
+              <a:t>previsões</a:t>
+            </a:r>
+            <a:r>
+              <a:rPr dirty="0"/>
+              <a:t> (</a:t>
+            </a:r>
+            <a:r>
+              <a:rPr dirty="0" err="1"/>
+              <a:t>não</a:t>
+            </a:r>
+            <a:r>
+              <a:rPr dirty="0"/>
+              <a:t> </a:t>
+            </a:r>
+            <a:r>
+              <a:rPr dirty="0" err="1"/>
+              <a:t>é</a:t>
+            </a:r>
+            <a:r>
+              <a:rPr dirty="0"/>
+              <a:t> </a:t>
+            </a:r>
+            <a:r>
+              <a:rPr dirty="0" err="1"/>
+              <a:t>aposta</a:t>
+            </a:r>
+            <a:r>
+              <a:rPr dirty="0"/>
+              <a:t>, </a:t>
+            </a:r>
+            <a:r>
+              <a:rPr dirty="0" err="1"/>
+              <a:t>não</a:t>
+            </a:r>
+            <a:r>
+              <a:rPr dirty="0"/>
+              <a:t> </a:t>
+            </a:r>
+            <a:r>
+              <a:rPr dirty="0" err="1"/>
+              <a:t>é</a:t>
+            </a:r>
+            <a:r>
+              <a:rPr dirty="0"/>
+              <a:t> cassino). Três </a:t>
+            </a:r>
+            <a:r>
+              <a:rPr dirty="0" err="1"/>
+              <a:t>pilares</a:t>
+            </a:r>
+            <a:r>
+              <a:rPr dirty="0"/>
+              <a:t>: </a:t>
+            </a:r>
+            <a:r>
+              <a:rPr dirty="0" err="1"/>
+              <a:t>Econômico</a:t>
+            </a:r>
+            <a:r>
+              <a:rPr dirty="0"/>
+              <a:t>, Liga, Privadas. Moeda virtual: </a:t>
+            </a:r>
+            <a:r>
+              <a:rPr dirty="0" err="1"/>
+              <a:t>Zafes</a:t>
+            </a:r>
+            <a:r>
+              <a:rPr dirty="0"/>
+              <a:t>. </a:t>
+            </a:r>
+            <a:r>
+              <a:rPr dirty="0" err="1"/>
+              <a:t>Prêmios</a:t>
+            </a:r>
+            <a:r>
+              <a:rPr dirty="0"/>
+              <a:t> reais via PIX no concurso. </a:t>
+            </a:r>
+            <a:r>
+              <a:rPr dirty="0" err="1"/>
+              <a:t>Apresentação</a:t>
+            </a:r>
+            <a:r>
+              <a:rPr dirty="0"/>
+              <a:t>: Luc Sapoznik e Lorenzo Fragali.</a:t>
             </a:r>
           </a:p>
         </p:txBody>
@@ -377,7 +479,7 @@
           <a:lstStyle/>
           <a:p>
             <a:r>
-              <a:t>Curto prazo (1-3 meses): Criar CNPJ, comprar domínio zafe.com.br. Email corporativo @zafe.com.br, conta bancária PJ. Marketing: redes sociais, ads 18-35 anos. Rebrand para Zafe, meta 1.000 usuários, app PWA.</a:t>
+              <a:t>Concurso: R$ 2.500 via PIX (Lei 5.768/71). Brier Score: maior acurácia agregada, mínimo 3 categorias. Base legal: Dispensa SECAP (patrocínio cobre prêmios). Concurso Major: R$ 10k-25k (exige SECAP, 10% patrocinador).</a:t>
             </a:r>
           </a:p>
         </p:txBody>
@@ -447,7 +549,7 @@
           <a:lstStyle/>
           <a:p>
             <a:r>
-              <a:t>Médio prazo: Zafe Premium R$ 19,90/mês, concurso trimestral R$ 25k. Longo prazo: Zafes viram moeda de fidelidade, conversão em descontos. Visão: liderança nacional, 100k+ usuários. Venda de dados B2B (sabedoria das multidões).</a:t>
+              <a:t>Curto prazo (1-3 meses): Criar CNPJ, comprar domínio zafe.com.br. Email corporativo @zafe.com.br, conta bancária PJ. Marketing: redes sociais, ads 18-35 anos. Rebrand para Zafe, meta 1.000 usuários, app PWA.</a:t>
             </a:r>
           </a:p>
         </p:txBody>
@@ -517,6 +619,76 @@
           <a:lstStyle/>
           <a:p>
             <a:r>
+              <a:t>Médio prazo: Zafe Premium R$ 19,90/mês, concurso trimestral R$ 25k. Longo prazo: Zafes viram moeda de fidelidade, conversão em descontos. Visão: liderança nacional, 100k+ usuários. Venda de dados B2B (sabedoria das multidões).</a:t>
+            </a:r>
+          </a:p>
+        </p:txBody>
+      </p:sp>
+      <p:sp>
+        <p:nvSpPr>
+          <p:cNvPr id="4" name="Slide Number Placeholder 3"/>
+          <p:cNvSpPr>
+            <a:spLocks noGrp="1"/>
+          </p:cNvSpPr>
+          <p:nvPr>
+            <p:ph type="sldNum" sz="quarter" idx="5"/>
+          </p:nvPr>
+        </p:nvSpPr>
+        <p:spPr/>
+      </p:sp>
+    </p:spTree>
+  </p:cSld>
+  <p:clrMapOvr>
+    <a:masterClrMapping/>
+  </p:clrMapOvr>
+</p:notes>
+</file>
+
+<file path=ppt/notesSlides/notesSlide13.xml><?xml version="1.0" encoding="utf-8"?>
+<p:notes xmlns:a="http://schemas.openxmlformats.org/drawingml/2006/main" xmlns:r="http://schemas.openxmlformats.org/officeDocument/2006/relationships" xmlns:p="http://schemas.openxmlformats.org/presentationml/2006/main">
+  <p:cSld>
+    <p:spTree>
+      <p:nvGrpSpPr>
+        <p:cNvPr id="1" name=""/>
+        <p:cNvGrpSpPr/>
+        <p:nvPr/>
+      </p:nvGrpSpPr>
+      <p:grpSpPr>
+        <a:xfrm>
+          <a:off x="0" y="0"/>
+          <a:ext cx="0" cy="0"/>
+          <a:chOff x="0" y="0"/>
+          <a:chExt cx="0" cy="0"/>
+        </a:xfrm>
+      </p:grpSpPr>
+      <p:sp>
+        <p:nvSpPr>
+          <p:cNvPr id="2" name="Slide Image Placeholder 1"/>
+          <p:cNvSpPr>
+            <a:spLocks noGrp="1" noRot="1" noChangeAspect="1"/>
+          </p:cNvSpPr>
+          <p:nvPr>
+            <p:ph type="sldImg" idx="2"/>
+          </p:nvPr>
+        </p:nvSpPr>
+        <p:spPr/>
+      </p:sp>
+      <p:sp>
+        <p:nvSpPr>
+          <p:cNvPr id="3" name="Notes Placeholder 2"/>
+          <p:cNvSpPr>
+            <a:spLocks noGrp="1"/>
+          </p:cNvSpPr>
+          <p:nvPr>
+            <p:ph type="body" sz="quarter" idx="3"/>
+          </p:nvPr>
+        </p:nvSpPr>
+        <p:spPr/>
+        <p:txBody>
+          <a:bodyPr/>
+          <a:lstStyle/>
+          <a:p>
+            <a:r>
               <a:t>Fechamento: Zafe é a liga de previsões do Brasil (100% legal). Lei 5.768/71 + CMN 5.298: sem apostas, sem depósitos reais. Prêmios reais via PIX no concurso, 4 camadas de resolução. Obrigado pela atenção. zafe-rho.vercel.app → zafe.com.br.</a:t>
             </a:r>
           </a:p>
@@ -657,7 +829,7 @@
           <a:lstStyle/>
           <a:p>
             <a:r>
-              <a:t>Problema: brasileiro proibido de prever eventos (CMN 5.298/2026). Casas de aposta exploram dependência. Solução: Zafe como concurso legal. Sem dinheiro real, foco em habilidade e curadoria via IA (Premium).</a:t>
+              <a:t>Estado atual: maio/2026, usando Zafes como moeda virtual. Sistema 4 camadas: 87% sucesso na resolução automática. Objetivo: 1.000 usuários ativos na fase beta. Com 1000 usuários: migramos para lançamento oficial.</a:t>
             </a:r>
           </a:p>
         </p:txBody>
@@ -727,7 +899,7 @@
           <a:lstStyle/>
           <a:p>
             <a:r>
-              <a:t>Econômico: palpites sobre indicadores econômicos (Z$ virtual). Apenas admin cria eventos (Selic, IPCA, Dólar, Bitcoin, Ibovespa). Mercado secundário com order book FIFO. Lei 5.768/71.</a:t>
+              <a:t>Problema: brasileiro proibido de prever eventos (CMN 5.298/2026). Casas de aposta exploram dependência. Solução: Zafe como concurso legal. Sem dinheiro real, foco em habilidade e curadoria via IA (Premium).</a:t>
             </a:r>
           </a:p>
         </p:txBody>
@@ -797,7 +969,7 @@
           <a:lstStyle/>
           <a:p>
             <a:r>
-              <a:t>Liga: carro-chefe da Zafe (esporte, política, BBB, Oscar, tecnologia). Usuários criam eventos (aprovação admin). Moeda: Z$ virtual. Ranking por Brier Score, mínimo 30 previsões/mês, 3 categorias. Banner do concurso com inscrição grátis.</a:t>
+              <a:t>Econômico: palpites sobre indicadores econômicos (Z$ virtual). Apenas admin cria eventos (Selic, IPCA, Dólar, Bitcoin, Ibovespa). Mercado secundário com order book FIFO. Lei 5.768/71.</a:t>
             </a:r>
           </a:p>
         </p:txBody>
@@ -867,7 +1039,7 @@
           <a:lstStyle/>
           <a:p>
             <a:r>
-              <a:t>Concurso: R$ 2.500 via PIX (Lei 5.768/71). Brier Score: maior acurácia agregada, mínimo 3 categorias. Base legal: Dispensa SECAP (patrocínio cobre prêmios). Concurso Major: R$ 10k-25k (exige SECAP, 10% patrocinador).</a:t>
+              <a:t>Liga: carro-chefe da Zafe (esporte, política, BBB, Oscar, tecnologia). Usuários criam eventos (aprovação admin). Moeda: Z$ virtual. Ranking por Brier Score, mínimo 30 previsões/mês, 3 categorias. Banner do concurso com inscrição grátis.</a:t>
             </a:r>
           </a:p>
         </p:txBody>
@@ -937,7 +1109,7 @@
           <a:lstStyle/>
           <a:p>
             <a:r>
-              <a:t>Privadas: bolão entre amigos (4 travas legais obrigatórias). Mercado fechado, sem revenda, limite 5.000 Z$/ano por par. Futuro: converter Z$ em descontos reais via parcerias. Sistema de Juízes: divergência na supermaioria (67%).</a:t>
+              <a:t>Concurso: R$ 2.500 via PIX (Lei 5.768/71). Brier Score: maior acurácia agregada, mínimo 3 categorias. Base legal: Dispensa SECAP (patrocínio cobre prêmios). Concurso Major: R$ 10k-25k (exige SECAP, 10% patrocinador).</a:t>
             </a:r>
           </a:p>
         </p:txBody>
@@ -1007,7 +1179,7 @@
           <a:lstStyle/>
           <a:p>
             <a:r>
-              <a:t>Sistema de 4 camadas: APIs fixas, IA com dupla verificação, retry automático, reembolso. Taxa: 87% resolução automática, 5% reembolso (eventos subjetivos). APIs: Banco Central, Yahoo Finance, CoinGecko, TSE. IA: 2 checks independentes, confiança ≥85%.</a:t>
+              <a:t>Privadas: bolão entre amigos (4 travas legais obrigatórias). Mercado fechado, sem revenda, limite 5.000 Z$/ano por par. Futuro: converter Z$ em descontos reais via parcerias. Sistema de Juízes: divergência na supermaioria (67%).</a:t>
             </a:r>
           </a:p>
         </p:txBody>
@@ -1077,7 +1249,7 @@
           <a:lstStyle/>
           <a:p>
             <a:r>
-              <a:t>Estado atual: maio/2026, usando Zafes como moeda virtual. Sistema 4 camadas: 87% sucesso na resolução automática. Objetivo: 1.000 usuários ativos na fase beta. Com 1000 usuários: migramos para lançamento oficial.</a:t>
+              <a:t>Sistema de 4 camadas: APIs fixas, IA com dupla verificação, retry automático, reembolso. Taxa: 87% resolução automática, 5% reembolso (eventos subjetivos). APIs: Banco Central, Yahoo Finance, CoinGecko, TSE. IA: 2 checks independentes, confiança ≥85%.</a:t>
             </a:r>
           </a:p>
         </p:txBody>
@@ -4245,7 +4417,7 @@
               </a:defRPr>
             </a:pPr>
             <a:r>
-              <a:t>Curto Prazo (1-3 meses)</a:t>
+              <a:t>Plano Futuro: Zafe Premium</a:t>
             </a:r>
           </a:p>
         </p:txBody>
@@ -4280,7 +4452,7 @@
               </a:defRPr>
             </a:pPr>
             <a:r>
-              <a:t>Estruturação Jurídica e Digital</a:t>
+              <a:t>Concurso Pago</a:t>
             </a:r>
           </a:p>
         </p:txBody>
@@ -4293,8 +4465,8 @@
         </p:nvSpPr>
         <p:spPr>
           <a:xfrm>
-            <a:off x="914400" y="2377440"/>
-            <a:ext cx="5029200" cy="1828800"/>
+            <a:off x="1066800" y="2363257"/>
+            <a:ext cx="5029200" cy="830997"/>
           </a:xfrm>
           <a:prstGeom prst="rect">
             <a:avLst/>
@@ -4315,8 +4487,30 @@
               </a:defRPr>
             </a:pPr>
             <a:r>
-              <a:t>• Criar CNPJ: Constituir empresa formalmente</a:t>
-            </a:r>
+              <a:rPr dirty="0"/>
+              <a:t>• Entrada: R$ 10 </a:t>
+            </a:r>
+            <a:r>
+              <a:rPr dirty="0" err="1"/>
+              <a:t>por</a:t>
+            </a:r>
+            <a:r>
+              <a:rPr dirty="0"/>
+              <a:t> </a:t>
+            </a:r>
+            <a:r>
+              <a:rPr dirty="0" err="1"/>
+              <a:t>mês</a:t>
+            </a:r>
+            <a:r>
+              <a:rPr dirty="0"/>
+              <a:t> para </a:t>
+            </a:r>
+            <a:r>
+              <a:rPr dirty="0" err="1"/>
+              <a:t>participar</a:t>
+            </a:r>
+            <a:endParaRPr dirty="0"/>
           </a:p>
           <a:p>
             <a:pPr algn="l">
@@ -4327,8 +4521,30 @@
               </a:defRPr>
             </a:pPr>
             <a:r>
-              <a:t>• Comprar Domínio: zafe.com.br (migração de zafe-rho.vercel.app)</a:t>
-            </a:r>
+              <a:rPr dirty="0"/>
+              <a:t>• </a:t>
+            </a:r>
+            <a:r>
+              <a:rPr dirty="0" err="1"/>
+              <a:t>Prêmios</a:t>
+            </a:r>
+            <a:r>
+              <a:rPr dirty="0"/>
+              <a:t> </a:t>
+            </a:r>
+            <a:r>
+              <a:rPr dirty="0" err="1"/>
+              <a:t>significativamente</a:t>
+            </a:r>
+            <a:r>
+              <a:rPr dirty="0"/>
+              <a:t> </a:t>
+            </a:r>
+            <a:r>
+              <a:rPr dirty="0" err="1"/>
+              <a:t>maiores</a:t>
+            </a:r>
+            <a:endParaRPr dirty="0"/>
           </a:p>
           <a:p>
             <a:pPr algn="l">
@@ -4339,19 +4555,8 @@
               </a:defRPr>
             </a:pPr>
             <a:r>
-              <a:t>• Email Corporativo: @zafe.com.br</a:t>
-            </a:r>
-          </a:p>
-          <a:p>
-            <a:pPr algn="l">
-              <a:defRPr sz="1600">
-                <a:solidFill>
-                  <a:srgbClr val="FFFFFF"/>
-                </a:solidFill>
-              </a:defRPr>
-            </a:pPr>
-            <a:r>
-              <a:t>• Conta Bancária PJ: Receber assinaturas e pagar prêmios</a:t>
+              <a:rPr dirty="0"/>
+              <a:t>•</a:t>
             </a:r>
           </a:p>
         </p:txBody>
@@ -4364,8 +4569,8 @@
         </p:nvSpPr>
         <p:spPr>
           <a:xfrm>
-            <a:off x="6400800" y="1828800"/>
-            <a:ext cx="4572000" cy="457200"/>
+            <a:off x="914400" y="4754880"/>
+            <a:ext cx="4572000" cy="365760"/>
           </a:xfrm>
           <a:prstGeom prst="rect">
             <a:avLst/>
@@ -4379,14 +4584,14 @@
           <a:lstStyle/>
           <a:p>
             <a:pPr algn="l">
-              <a:defRPr sz="2400" b="1">
+              <a:defRPr sz="1800" b="1">
                 <a:solidFill>
                   <a:srgbClr val="86EFAC"/>
                 </a:solidFill>
               </a:defRPr>
             </a:pPr>
             <a:r>
-              <a:t>Marketing e Lançamento</a:t>
+              <a:t>Quando?</a:t>
             </a:r>
           </a:p>
         </p:txBody>
@@ -4399,8 +4604,8 @@
         </p:nvSpPr>
         <p:spPr>
           <a:xfrm>
-            <a:off x="6400800" y="2377440"/>
-            <a:ext cx="5029200" cy="2286000"/>
+            <a:off x="914400" y="5120640"/>
+            <a:ext cx="5029200" cy="830997"/>
           </a:xfrm>
           <a:prstGeom prst="rect">
             <a:avLst/>
@@ -4414,67 +4619,551 @@
           <a:lstStyle/>
           <a:p>
             <a:pPr algn="l">
-              <a:defRPr sz="1600">
-                <a:solidFill>
-                  <a:srgbClr val="FFFFFF"/>
-                </a:solidFill>
-              </a:defRPr>
-            </a:pPr>
-            <a:r>
-              <a:t>• Criar Redes Sociais: Instagram, Twitter, TikTok, LinkedIn</a:t>
-            </a:r>
-          </a:p>
-          <a:p>
-            <a:pPr algn="l">
-              <a:defRPr sz="1600">
-                <a:solidFill>
-                  <a:srgbClr val="FFFFFF"/>
-                </a:solidFill>
-              </a:defRPr>
-            </a:pPr>
-            <a:r>
-              <a:t>• Campanha de Advertising: Ads 18-35 anos</a:t>
-            </a:r>
-          </a:p>
-          <a:p>
-            <a:pPr algn="l">
-              <a:defRPr sz="1600">
-                <a:solidFill>
-                  <a:srgbClr val="FFFFFF"/>
-                </a:solidFill>
-              </a:defRPr>
-            </a:pPr>
-            <a:r>
-              <a:t>• Lançar Oficialmente: Rebrand Zafes para Zafe</a:t>
-            </a:r>
-          </a:p>
-          <a:p>
-            <a:pPr algn="l">
-              <a:defRPr sz="1600">
-                <a:solidFill>
-                  <a:srgbClr val="FFFFFF"/>
-                </a:solidFill>
-              </a:defRPr>
-            </a:pPr>
-            <a:r>
-              <a:t>• Alcançar 1.000 usuários: Tração orgânica + paga</a:t>
-            </a:r>
-          </a:p>
-          <a:p>
-            <a:pPr algn="l">
-              <a:defRPr sz="1600">
-                <a:solidFill>
-                  <a:srgbClr val="FFFFFF"/>
-                </a:solidFill>
-              </a:defRPr>
-            </a:pPr>
-            <a:r>
-              <a:t>• App Mobile PWA: Notificações nativas</a:t>
+              <a:defRPr sz="1400">
+                <a:solidFill>
+                  <a:srgbClr val="C8C8C8"/>
+                </a:solidFill>
+              </a:defRPr>
+            </a:pPr>
+            <a:r>
+              <a:rPr sz="1600" dirty="0"/>
+              <a:t>Quando </a:t>
+            </a:r>
+            <a:r>
+              <a:rPr sz="1600" dirty="0" err="1"/>
+              <a:t>tivermos</a:t>
+            </a:r>
+            <a:r>
+              <a:rPr sz="1600" dirty="0"/>
+              <a:t> </a:t>
+            </a:r>
+            <a:r>
+              <a:rPr sz="1600" dirty="0" err="1"/>
+              <a:t>uma</a:t>
+            </a:r>
+            <a:r>
+              <a:rPr sz="1600" dirty="0"/>
+              <a:t> base grande de </a:t>
+            </a:r>
+            <a:r>
+              <a:rPr sz="1600" dirty="0" err="1"/>
+              <a:t>usuários</a:t>
+            </a:r>
+            <a:r>
+              <a:rPr sz="1600" dirty="0"/>
+              <a:t> </a:t>
+            </a:r>
+            <a:r>
+              <a:rPr sz="1600" dirty="0" err="1"/>
+              <a:t>ativos</a:t>
+            </a:r>
+            <a:r>
+              <a:rPr sz="1600" dirty="0"/>
+              <a:t>.</a:t>
+            </a:r>
+          </a:p>
+          <a:p>
+            <a:pPr algn="l">
+              <a:defRPr sz="1400">
+                <a:solidFill>
+                  <a:srgbClr val="C8C8C8"/>
+                </a:solidFill>
+              </a:defRPr>
+            </a:pPr>
+            <a:r>
+              <a:rPr sz="1600" dirty="0"/>
+              <a:t>Primeiro </a:t>
+            </a:r>
+            <a:r>
+              <a:rPr sz="1600" dirty="0" err="1"/>
+              <a:t>validamos</a:t>
+            </a:r>
+            <a:r>
+              <a:rPr sz="1600" dirty="0"/>
+              <a:t> o </a:t>
+            </a:r>
+            <a:r>
+              <a:rPr sz="1600" dirty="0" err="1"/>
+              <a:t>modelo</a:t>
+            </a:r>
+            <a:r>
+              <a:rPr sz="1600" dirty="0"/>
+              <a:t> </a:t>
+            </a:r>
+            <a:r>
+              <a:rPr sz="1600" dirty="0" err="1"/>
+              <a:t>gratuito</a:t>
+            </a:r>
+            <a:r>
+              <a:rPr sz="1600" dirty="0"/>
+              <a:t>, </a:t>
+            </a:r>
+            <a:r>
+              <a:rPr sz="1600" dirty="0" err="1"/>
+              <a:t>depois</a:t>
+            </a:r>
+            <a:r>
+              <a:rPr sz="1600" dirty="0"/>
+              <a:t> </a:t>
+            </a:r>
+            <a:r>
+              <a:rPr sz="1600" dirty="0" err="1"/>
+              <a:t>monetizamos</a:t>
+            </a:r>
+            <a:r>
+              <a:rPr sz="1600" dirty="0"/>
+              <a:t>.</a:t>
+            </a:r>
+          </a:p>
+        </p:txBody>
+      </p:sp>
+      <p:sp>
+        <p:nvSpPr>
+          <p:cNvPr id="7" name="TextBox 6"/>
+          <p:cNvSpPr txBox="1"/>
+          <p:nvPr/>
+        </p:nvSpPr>
+        <p:spPr>
+          <a:xfrm>
+            <a:off x="6400800" y="1685949"/>
+            <a:ext cx="4572000" cy="457200"/>
+          </a:xfrm>
+          <a:prstGeom prst="rect">
+            <a:avLst/>
+          </a:prstGeom>
+          <a:noFill/>
+        </p:spPr>
+        <p:txBody>
+          <a:bodyPr wrap="square">
+            <a:spAutoFit/>
+          </a:bodyPr>
+          <a:lstStyle/>
+          <a:p>
+            <a:pPr algn="l">
+              <a:defRPr sz="2400" b="1">
+                <a:solidFill>
+                  <a:srgbClr val="86EFAC"/>
+                </a:solidFill>
+              </a:defRPr>
+            </a:pPr>
+            <a:r>
+              <a:rPr dirty="0" err="1"/>
+              <a:t>Zafe</a:t>
+            </a:r>
+            <a:r>
+              <a:rPr dirty="0"/>
+              <a:t> Premium</a:t>
+            </a:r>
+          </a:p>
+        </p:txBody>
+      </p:sp>
+      <p:sp>
+        <p:nvSpPr>
+          <p:cNvPr id="8" name="TextBox 7"/>
+          <p:cNvSpPr txBox="1"/>
+          <p:nvPr/>
+        </p:nvSpPr>
+        <p:spPr>
+          <a:xfrm>
+            <a:off x="5252484" y="2081480"/>
+            <a:ext cx="5029200" cy="1323439"/>
+          </a:xfrm>
+          <a:prstGeom prst="rect">
+            <a:avLst/>
+          </a:prstGeom>
+          <a:noFill/>
+        </p:spPr>
+        <p:txBody>
+          <a:bodyPr wrap="square">
+            <a:spAutoFit/>
+          </a:bodyPr>
+          <a:lstStyle/>
+          <a:p>
+            <a:pPr algn="l">
+              <a:defRPr sz="1400" b="0">
+                <a:solidFill>
+                  <a:srgbClr val="FFFFFF"/>
+                </a:solidFill>
+              </a:defRPr>
+            </a:pPr>
+            <a:r>
+              <a:rPr sz="1600" dirty="0" err="1"/>
+              <a:t>Assinatura</a:t>
+            </a:r>
+            <a:r>
+              <a:rPr sz="1600" dirty="0"/>
+              <a:t> com </a:t>
+            </a:r>
+            <a:r>
+              <a:rPr sz="1600" dirty="0" err="1"/>
+              <a:t>benefícios</a:t>
+            </a:r>
+            <a:r>
+              <a:rPr sz="1600" dirty="0"/>
+              <a:t> </a:t>
+            </a:r>
+            <a:r>
+              <a:rPr sz="1600" dirty="0" err="1"/>
+              <a:t>exclusivos</a:t>
+            </a:r>
+            <a:r>
+              <a:rPr sz="1600" dirty="0"/>
+              <a:t> para </a:t>
+            </a:r>
+            <a:r>
+              <a:rPr sz="1600" dirty="0" err="1"/>
+              <a:t>preditores</a:t>
+            </a:r>
+            <a:r>
+              <a:rPr sz="1600" dirty="0"/>
+              <a:t> </a:t>
+            </a:r>
+            <a:r>
+              <a:rPr sz="1600" dirty="0" err="1"/>
+              <a:t>sérios</a:t>
+            </a:r>
+            <a:r>
+              <a:rPr sz="1600" dirty="0"/>
+              <a:t>.</a:t>
+            </a:r>
+            <a:endParaRPr lang="pt-BR" sz="1600" dirty="0"/>
+          </a:p>
+          <a:p>
+            <a:pPr algn="l">
+              <a:defRPr sz="1400" b="0">
+                <a:solidFill>
+                  <a:srgbClr val="FFFFFF"/>
+                </a:solidFill>
+              </a:defRPr>
+            </a:pPr>
+            <a:endParaRPr lang="pt-BR" sz="1600" dirty="0"/>
+          </a:p>
+          <a:p>
+            <a:pPr algn="l">
+              <a:defRPr sz="1400" b="0">
+                <a:solidFill>
+                  <a:srgbClr val="FFFFFF"/>
+                </a:solidFill>
+              </a:defRPr>
+            </a:pPr>
+            <a:r>
+              <a:rPr lang="pt-BR" sz="1600" dirty="0"/>
+              <a:t>Ganha benefícios e ajuda pra acertar eventos- ganha mais informação</a:t>
+            </a:r>
+            <a:endParaRPr sz="1600" dirty="0"/>
+          </a:p>
+        </p:txBody>
+      </p:sp>
+      <p:sp>
+        <p:nvSpPr>
+          <p:cNvPr id="9" name="TextBox 8"/>
+          <p:cNvSpPr txBox="1"/>
+          <p:nvPr/>
+        </p:nvSpPr>
+        <p:spPr>
+          <a:xfrm>
+            <a:off x="1224518" y="3337560"/>
+            <a:ext cx="4572000" cy="365760"/>
+          </a:xfrm>
+          <a:prstGeom prst="rect">
+            <a:avLst/>
+          </a:prstGeom>
+          <a:noFill/>
+        </p:spPr>
+        <p:txBody>
+          <a:bodyPr wrap="square">
+            <a:spAutoFit/>
+          </a:bodyPr>
+          <a:lstStyle/>
+          <a:p>
+            <a:pPr algn="l">
+              <a:defRPr sz="1800" b="1">
+                <a:solidFill>
+                  <a:srgbClr val="86EFAC"/>
+                </a:solidFill>
+              </a:defRPr>
+            </a:pPr>
+            <a:r>
+              <a:rPr dirty="0"/>
+              <a:t>Modelo de </a:t>
+            </a:r>
+            <a:r>
+              <a:rPr dirty="0" err="1"/>
+              <a:t>Receita</a:t>
+            </a:r>
+            <a:endParaRPr dirty="0"/>
+          </a:p>
+        </p:txBody>
+      </p:sp>
+      <p:sp>
+        <p:nvSpPr>
+          <p:cNvPr id="10" name="TextBox 9"/>
+          <p:cNvSpPr txBox="1"/>
+          <p:nvPr/>
+        </p:nvSpPr>
+        <p:spPr>
+          <a:xfrm>
+            <a:off x="914400" y="3731222"/>
+            <a:ext cx="5029200" cy="830997"/>
+          </a:xfrm>
+          <a:prstGeom prst="rect">
+            <a:avLst/>
+          </a:prstGeom>
+          <a:noFill/>
+        </p:spPr>
+        <p:txBody>
+          <a:bodyPr wrap="square">
+            <a:spAutoFit/>
+          </a:bodyPr>
+          <a:lstStyle/>
+          <a:p>
+            <a:pPr algn="l">
+              <a:defRPr sz="1400" b="0">
+                <a:solidFill>
+                  <a:srgbClr val="FFFFFF"/>
+                </a:solidFill>
+              </a:defRPr>
+            </a:pPr>
+            <a:r>
+              <a:rPr sz="1600" dirty="0"/>
+              <a:t>• R$ 10/</a:t>
+            </a:r>
+            <a:r>
+              <a:rPr sz="1600" dirty="0" err="1"/>
+              <a:t>mês</a:t>
+            </a:r>
+            <a:r>
+              <a:rPr sz="1600" dirty="0"/>
+              <a:t> </a:t>
+            </a:r>
+            <a:r>
+              <a:rPr sz="1600" dirty="0" err="1"/>
+              <a:t>por</a:t>
+            </a:r>
+            <a:r>
+              <a:rPr sz="1600" dirty="0"/>
+              <a:t> </a:t>
+            </a:r>
+            <a:r>
+              <a:rPr sz="1600" dirty="0" err="1"/>
+              <a:t>participante</a:t>
+            </a:r>
+            <a:r>
+              <a:rPr sz="1600" dirty="0"/>
+              <a:t> do concurso </a:t>
+            </a:r>
+            <a:r>
+              <a:rPr sz="1600" dirty="0" err="1"/>
+              <a:t>pago</a:t>
+            </a:r>
+            <a:endParaRPr sz="1600" dirty="0"/>
+          </a:p>
+          <a:p>
+            <a:pPr algn="l">
+              <a:defRPr sz="1400" b="0">
+                <a:solidFill>
+                  <a:srgbClr val="FFFFFF"/>
+                </a:solidFill>
+              </a:defRPr>
+            </a:pPr>
+            <a:r>
+              <a:rPr sz="1600" dirty="0"/>
+              <a:t>• </a:t>
+            </a:r>
+            <a:r>
+              <a:rPr sz="1600" dirty="0" err="1"/>
+              <a:t>Assinatura</a:t>
+            </a:r>
+            <a:r>
+              <a:rPr sz="1600" dirty="0"/>
+              <a:t> </a:t>
+            </a:r>
+            <a:r>
+              <a:rPr sz="1600" dirty="0" err="1"/>
+              <a:t>Zafe</a:t>
+            </a:r>
+            <a:r>
+              <a:rPr sz="1600" dirty="0"/>
+              <a:t> Premium (features </a:t>
+            </a:r>
+            <a:r>
+              <a:rPr sz="1600" dirty="0" err="1"/>
+              <a:t>exclusivas</a:t>
+            </a:r>
+            <a:r>
+              <a:rPr sz="1600" dirty="0"/>
+              <a:t>)</a:t>
+            </a:r>
+          </a:p>
+          <a:p>
+            <a:pPr algn="l">
+              <a:defRPr sz="1400" b="0">
+                <a:solidFill>
+                  <a:srgbClr val="FFFFFF"/>
+                </a:solidFill>
+              </a:defRPr>
+            </a:pPr>
+            <a:r>
+              <a:rPr sz="1600" dirty="0"/>
+              <a:t>• </a:t>
+            </a:r>
+            <a:r>
+              <a:rPr sz="1600" dirty="0" err="1"/>
+              <a:t>Patrocínios</a:t>
+            </a:r>
+            <a:r>
+              <a:rPr sz="1600" dirty="0"/>
+              <a:t> </a:t>
+            </a:r>
+            <a:r>
+              <a:rPr sz="1600" dirty="0" err="1"/>
+              <a:t>corporativos</a:t>
+            </a:r>
+            <a:r>
+              <a:rPr sz="1600" dirty="0"/>
+              <a:t> </a:t>
+            </a:r>
+            <a:r>
+              <a:rPr sz="1600" dirty="0" err="1"/>
+              <a:t>nos</a:t>
+            </a:r>
+            <a:r>
+              <a:rPr sz="1600" dirty="0"/>
+              <a:t> concursos</a:t>
+            </a:r>
+          </a:p>
+        </p:txBody>
+      </p:sp>
+      <p:sp>
+        <p:nvSpPr>
+          <p:cNvPr id="11" name="TextBox 10"/>
+          <p:cNvSpPr txBox="1"/>
+          <p:nvPr/>
+        </p:nvSpPr>
+        <p:spPr>
+          <a:xfrm>
+            <a:off x="6400800" y="4754880"/>
+            <a:ext cx="5029200" cy="584775"/>
+          </a:xfrm>
+          <a:prstGeom prst="rect">
+            <a:avLst/>
+          </a:prstGeom>
+          <a:noFill/>
+        </p:spPr>
+        <p:txBody>
+          <a:bodyPr wrap="square">
+            <a:spAutoFit/>
+          </a:bodyPr>
+          <a:lstStyle/>
+          <a:p>
+            <a:pPr algn="l">
+              <a:defRPr sz="1400" b="0">
+                <a:solidFill>
+                  <a:srgbClr val="EAB308"/>
+                </a:solidFill>
+              </a:defRPr>
+            </a:pPr>
+            <a:r>
+              <a:rPr sz="1600" dirty="0"/>
+              <a:t>Fase </a:t>
+            </a:r>
+            <a:r>
+              <a:rPr sz="1600" dirty="0" err="1"/>
+              <a:t>atual</a:t>
+            </a:r>
+            <a:r>
+              <a:rPr sz="1600" dirty="0"/>
+              <a:t>: 100% </a:t>
+            </a:r>
+            <a:r>
+              <a:rPr sz="1600" dirty="0" err="1"/>
+              <a:t>gratuita</a:t>
+            </a:r>
+            <a:r>
+              <a:rPr sz="1600" dirty="0"/>
+              <a:t>. </a:t>
+            </a:r>
+            <a:r>
+              <a:rPr sz="1600" dirty="0" err="1"/>
+              <a:t>Monetização</a:t>
+            </a:r>
+            <a:r>
+              <a:rPr sz="1600" dirty="0"/>
+              <a:t> </a:t>
+            </a:r>
+            <a:r>
+              <a:rPr sz="1600" dirty="0" err="1"/>
+              <a:t>só</a:t>
+            </a:r>
+            <a:r>
+              <a:rPr sz="1600" dirty="0"/>
+              <a:t> </a:t>
+            </a:r>
+            <a:r>
+              <a:rPr sz="1600" dirty="0" err="1"/>
+              <a:t>após</a:t>
+            </a:r>
+            <a:r>
+              <a:rPr sz="1600" dirty="0"/>
+              <a:t> </a:t>
+            </a:r>
+            <a:r>
+              <a:rPr sz="1600" dirty="0" err="1"/>
+              <a:t>atingir</a:t>
+            </a:r>
+            <a:r>
+              <a:rPr sz="1600" dirty="0"/>
+              <a:t> </a:t>
+            </a:r>
+            <a:r>
+              <a:rPr sz="1600" dirty="0" err="1"/>
+              <a:t>massa</a:t>
+            </a:r>
+            <a:r>
+              <a:rPr sz="1600" dirty="0"/>
+              <a:t> </a:t>
+            </a:r>
+            <a:r>
+              <a:rPr sz="1600" dirty="0" err="1"/>
+              <a:t>crítica</a:t>
+            </a:r>
+            <a:r>
+              <a:rPr sz="1600" dirty="0"/>
+              <a:t> de </a:t>
+            </a:r>
+            <a:r>
+              <a:rPr sz="1600" dirty="0" err="1"/>
+              <a:t>usuários</a:t>
+            </a:r>
+            <a:r>
+              <a:rPr sz="1600" dirty="0"/>
+              <a:t> e </a:t>
+            </a:r>
+            <a:r>
+              <a:rPr sz="1600" dirty="0" err="1"/>
+              <a:t>validar</a:t>
+            </a:r>
+            <a:r>
+              <a:rPr sz="1600" dirty="0"/>
+              <a:t> </a:t>
+            </a:r>
+            <a:r>
+              <a:rPr sz="1600" dirty="0" err="1"/>
+              <a:t>engajamento</a:t>
+            </a:r>
+            <a:r>
+              <a:rPr sz="1600" dirty="0"/>
+              <a:t>.</a:t>
             </a:r>
           </a:p>
         </p:txBody>
       </p:sp>
     </p:spTree>
+    <p:extLst>
+      <p:ext uri="{BB962C8B-B14F-4D97-AF65-F5344CB8AC3E}">
+        <p14:creationId xmlns:p14="http://schemas.microsoft.com/office/powerpoint/2010/main" val="2829991493"/>
+      </p:ext>
+    </p:extLst>
   </p:cSld>
   <p:clrMapOvr>
     <a:masterClrMapping/>
@@ -4537,7 +5226,7 @@
               </a:defRPr>
             </a:pPr>
             <a:r>
-              <a:t>Roadmap: Médio e Longo Prazo</a:t>
+              <a:t>Curto Prazo (1-3 meses)</a:t>
             </a:r>
           </a:p>
         </p:txBody>
@@ -4551,7 +5240,7 @@
         <p:spPr>
           <a:xfrm>
             <a:off x="914400" y="1828800"/>
-            <a:ext cx="3200400" cy="457200"/>
+            <a:ext cx="4572000" cy="457200"/>
           </a:xfrm>
           <a:prstGeom prst="rect">
             <a:avLst/>
@@ -4565,14 +5254,14 @@
           <a:lstStyle/>
           <a:p>
             <a:pPr algn="l">
-              <a:defRPr sz="2000" b="1">
+              <a:defRPr sz="2400" b="1">
                 <a:solidFill>
                   <a:srgbClr val="86EFAC"/>
                 </a:solidFill>
               </a:defRPr>
             </a:pPr>
             <a:r>
-              <a:t>Médio Prazo (3-6 meses)</a:t>
+              <a:t>Estruturação Jurídica e Digital</a:t>
             </a:r>
           </a:p>
         </p:txBody>
@@ -4586,7 +5275,7 @@
         <p:spPr>
           <a:xfrm>
             <a:off x="914400" y="2377440"/>
-            <a:ext cx="3474720" cy="1828800"/>
+            <a:ext cx="5029200" cy="1828800"/>
           </a:xfrm>
           <a:prstGeom prst="rect">
             <a:avLst/>
@@ -4600,62 +5289,50 @@
           <a:lstStyle/>
           <a:p>
             <a:pPr algn="l">
-              <a:defRPr sz="1400">
-                <a:solidFill>
-                  <a:srgbClr val="FFFFFF"/>
-                </a:solidFill>
-              </a:defRPr>
-            </a:pPr>
-            <a:r>
-              <a:t>• Zafe Premium (R$ 19,90/mês)</a:t>
-            </a:r>
-          </a:p>
-          <a:p>
-            <a:pPr algn="l">
-              <a:defRPr sz="1400">
-                <a:solidFill>
-                  <a:srgbClr val="FFFFFF"/>
-                </a:solidFill>
-              </a:defRPr>
-            </a:pPr>
-            <a:r>
-              <a:t>• Parcerias de patrocínio corporativo</a:t>
-            </a:r>
-          </a:p>
-          <a:p>
-            <a:pPr algn="l">
-              <a:defRPr sz="1400">
-                <a:solidFill>
-                  <a:srgbClr val="FFFFFF"/>
-                </a:solidFill>
-              </a:defRPr>
-            </a:pPr>
-            <a:r>
-              <a:t>• Concurso Trimestral R$ 25k</a:t>
-            </a:r>
-          </a:p>
-          <a:p>
-            <a:pPr algn="l">
-              <a:defRPr sz="1400">
-                <a:solidFill>
-                  <a:srgbClr val="FFFFFF"/>
-                </a:solidFill>
-              </a:defRPr>
-            </a:pPr>
-            <a:r>
-              <a:t>• Gamificação (badges, níveis, streaks)</a:t>
-            </a:r>
-          </a:p>
-          <a:p>
-            <a:pPr algn="l">
-              <a:defRPr sz="1400">
-                <a:solidFill>
-                  <a:srgbClr val="FFFFFF"/>
-                </a:solidFill>
-              </a:defRPr>
-            </a:pPr>
-            <a:r>
-              <a:t>• Recursos sociais (seguir previsores)</a:t>
+              <a:defRPr sz="1600">
+                <a:solidFill>
+                  <a:srgbClr val="FFFFFF"/>
+                </a:solidFill>
+              </a:defRPr>
+            </a:pPr>
+            <a:r>
+              <a:t>• Criar CNPJ: Constituir empresa formalmente</a:t>
+            </a:r>
+          </a:p>
+          <a:p>
+            <a:pPr algn="l">
+              <a:defRPr sz="1600">
+                <a:solidFill>
+                  <a:srgbClr val="FFFFFF"/>
+                </a:solidFill>
+              </a:defRPr>
+            </a:pPr>
+            <a:r>
+              <a:t>• Comprar Domínio: zafe.com.br (migração de zafe-rho.vercel.app)</a:t>
+            </a:r>
+          </a:p>
+          <a:p>
+            <a:pPr algn="l">
+              <a:defRPr sz="1600">
+                <a:solidFill>
+                  <a:srgbClr val="FFFFFF"/>
+                </a:solidFill>
+              </a:defRPr>
+            </a:pPr>
+            <a:r>
+              <a:t>• Email Corporativo: @zafe.com.br</a:t>
+            </a:r>
+          </a:p>
+          <a:p>
+            <a:pPr algn="l">
+              <a:defRPr sz="1600">
+                <a:solidFill>
+                  <a:srgbClr val="FFFFFF"/>
+                </a:solidFill>
+              </a:defRPr>
+            </a:pPr>
+            <a:r>
+              <a:t>• Conta Bancária PJ: Receber assinaturas e pagar prêmios</a:t>
             </a:r>
           </a:p>
         </p:txBody>
@@ -4668,8 +5345,8 @@
         </p:nvSpPr>
         <p:spPr>
           <a:xfrm>
-            <a:off x="4572000" y="1828800"/>
-            <a:ext cx="3200400" cy="457200"/>
+            <a:off x="6400800" y="1828800"/>
+            <a:ext cx="4572000" cy="457200"/>
           </a:xfrm>
           <a:prstGeom prst="rect">
             <a:avLst/>
@@ -4683,14 +5360,14 @@
           <a:lstStyle/>
           <a:p>
             <a:pPr algn="l">
-              <a:defRPr sz="2000" b="1">
+              <a:defRPr sz="2400" b="1">
                 <a:solidFill>
                   <a:srgbClr val="86EFAC"/>
                 </a:solidFill>
               </a:defRPr>
             </a:pPr>
             <a:r>
-              <a:t>Longo Prazo (6-12 meses)</a:t>
+              <a:t>Marketing e Lançamento</a:t>
             </a:r>
           </a:p>
         </p:txBody>
@@ -4703,8 +5380,8 @@
         </p:nvSpPr>
         <p:spPr>
           <a:xfrm>
-            <a:off x="4572000" y="2377440"/>
-            <a:ext cx="3474720" cy="1828800"/>
+            <a:off x="6400800" y="2377440"/>
+            <a:ext cx="5029200" cy="2286000"/>
           </a:xfrm>
           <a:prstGeom prst="rect">
             <a:avLst/>
@@ -4718,168 +5395,62 @@
           <a:lstStyle/>
           <a:p>
             <a:pPr algn="l">
-              <a:defRPr sz="1400">
-                <a:solidFill>
-                  <a:srgbClr val="FFFFFF"/>
-                </a:solidFill>
-              </a:defRPr>
-            </a:pPr>
-            <a:r>
-              <a:t>• Troca de Zafes: 10.000 Z$ = 10% desconto</a:t>
-            </a:r>
-          </a:p>
-          <a:p>
-            <a:pPr algn="l">
-              <a:defRPr sz="1400">
-                <a:solidFill>
-                  <a:srgbClr val="FFFFFF"/>
-                </a:solidFill>
-              </a:defRPr>
-            </a:pPr>
-            <a:r>
-              <a:t>• Zafes viram moeda de fidelidade</a:t>
-            </a:r>
-          </a:p>
-          <a:p>
-            <a:pPr algn="l">
-              <a:defRPr sz="1400">
-                <a:solidFill>
-                  <a:srgbClr val="FFFFFF"/>
-                </a:solidFill>
-              </a:defRPr>
-            </a:pPr>
-            <a:r>
-              <a:t>• Converter Z$ em descontos reais (parcerias)</a:t>
-            </a:r>
-          </a:p>
-          <a:p>
-            <a:pPr algn="l">
-              <a:defRPr sz="1400">
-                <a:solidFill>
-                  <a:srgbClr val="FFFFFF"/>
-                </a:solidFill>
-              </a:defRPr>
-            </a:pPr>
-            <a:r>
-              <a:t>• Venda de dados B2B (sabedoria das multidões)</a:t>
-            </a:r>
-          </a:p>
-          <a:p>
-            <a:pPr algn="l">
-              <a:defRPr sz="1400">
-                <a:solidFill>
-                  <a:srgbClr val="FFFFFF"/>
-                </a:solidFill>
-              </a:defRPr>
-            </a:pPr>
-            <a:r>
-              <a:t>• Premium escalado nacionalmente</a:t>
-            </a:r>
-          </a:p>
-        </p:txBody>
-      </p:sp>
-      <p:sp>
-        <p:nvSpPr>
-          <p:cNvPr id="7" name="TextBox 6"/>
-          <p:cNvSpPr txBox="1"/>
-          <p:nvPr/>
-        </p:nvSpPr>
-        <p:spPr>
-          <a:xfrm>
-            <a:off x="8229600" y="1828800"/>
-            <a:ext cx="3200400" cy="457200"/>
-          </a:xfrm>
-          <a:prstGeom prst="rect">
-            <a:avLst/>
-          </a:prstGeom>
-          <a:noFill/>
-        </p:spPr>
-        <p:txBody>
-          <a:bodyPr wrap="square">
-            <a:spAutoFit/>
-          </a:bodyPr>
-          <a:lstStyle/>
-          <a:p>
-            <a:pPr algn="l">
-              <a:defRPr sz="2000" b="1">
-                <a:solidFill>
-                  <a:srgbClr val="86EFAC"/>
-                </a:solidFill>
-              </a:defRPr>
-            </a:pPr>
-            <a:r>
-              <a:t>Visão de Expansão</a:t>
-            </a:r>
-          </a:p>
-        </p:txBody>
-      </p:sp>
-      <p:sp>
-        <p:nvSpPr>
-          <p:cNvPr id="8" name="TextBox 7"/>
-          <p:cNvSpPr txBox="1"/>
-          <p:nvPr/>
-        </p:nvSpPr>
-        <p:spPr>
-          <a:xfrm>
-            <a:off x="8229600" y="2377440"/>
-            <a:ext cx="3474720" cy="1463040"/>
-          </a:xfrm>
-          <a:prstGeom prst="rect">
-            <a:avLst/>
-          </a:prstGeom>
-          <a:noFill/>
-        </p:spPr>
-        <p:txBody>
-          <a:bodyPr wrap="square">
-            <a:spAutoFit/>
-          </a:bodyPr>
-          <a:lstStyle/>
-          <a:p>
-            <a:pPr algn="l">
-              <a:defRPr sz="1400">
-                <a:solidFill>
-                  <a:srgbClr val="FFFFFF"/>
-                </a:solidFill>
-              </a:defRPr>
-            </a:pPr>
-            <a:r>
-              <a:t>• Consolidação da marca nacionalmente</a:t>
-            </a:r>
-          </a:p>
-          <a:p>
-            <a:pPr algn="l">
-              <a:defRPr sz="1400">
-                <a:solidFill>
-                  <a:srgbClr val="FFFFFF"/>
-                </a:solidFill>
-              </a:defRPr>
-            </a:pPr>
-            <a:r>
-              <a:t>• Liderança em liga de previsões no Brasil</a:t>
-            </a:r>
-          </a:p>
-          <a:p>
-            <a:pPr algn="l">
-              <a:defRPr sz="1400">
-                <a:solidFill>
-                  <a:srgbClr val="FFFFFF"/>
-                </a:solidFill>
-              </a:defRPr>
-            </a:pPr>
-            <a:r>
-              <a:t>• Parcerias com varejistas</a:t>
-            </a:r>
-          </a:p>
-          <a:p>
-            <a:pPr algn="l">
-              <a:defRPr sz="1400">
-                <a:solidFill>
-                  <a:srgbClr val="FFFFFF"/>
-                </a:solidFill>
-              </a:defRPr>
-            </a:pPr>
-            <a:r>
-              <a:t>• Expansão para 100k+ usuários</a:t>
+              <a:defRPr sz="1600">
+                <a:solidFill>
+                  <a:srgbClr val="FFFFFF"/>
+                </a:solidFill>
+              </a:defRPr>
+            </a:pPr>
+            <a:r>
+              <a:t>• Criar Redes Sociais: Instagram, Twitter, TikTok, LinkedIn</a:t>
+            </a:r>
+          </a:p>
+          <a:p>
+            <a:pPr algn="l">
+              <a:defRPr sz="1600">
+                <a:solidFill>
+                  <a:srgbClr val="FFFFFF"/>
+                </a:solidFill>
+              </a:defRPr>
+            </a:pPr>
+            <a:r>
+              <a:t>• Campanha de Advertising: Ads 18-35 anos</a:t>
+            </a:r>
+          </a:p>
+          <a:p>
+            <a:pPr algn="l">
+              <a:defRPr sz="1600">
+                <a:solidFill>
+                  <a:srgbClr val="FFFFFF"/>
+                </a:solidFill>
+              </a:defRPr>
+            </a:pPr>
+            <a:r>
+              <a:t>• Lançar Oficialmente: Rebrand Zafes para Zafe</a:t>
+            </a:r>
+          </a:p>
+          <a:p>
+            <a:pPr algn="l">
+              <a:defRPr sz="1600">
+                <a:solidFill>
+                  <a:srgbClr val="FFFFFF"/>
+                </a:solidFill>
+              </a:defRPr>
+            </a:pPr>
+            <a:r>
+              <a:t>• Alcançar 1.000 usuários: Tração orgânica + paga</a:t>
+            </a:r>
+          </a:p>
+          <a:p>
+            <a:pPr algn="l">
+              <a:defRPr sz="1600">
+                <a:solidFill>
+                  <a:srgbClr val="FFFFFF"/>
+                </a:solidFill>
+              </a:defRPr>
+            </a:pPr>
+            <a:r>
+              <a:t>• App Mobile PWA: Notificações nativas</a:t>
             </a:r>
           </a:p>
         </p:txBody>
@@ -4925,8 +5496,8 @@
         </p:nvSpPr>
         <p:spPr>
           <a:xfrm>
-            <a:off x="914400" y="914400"/>
-            <a:ext cx="10058400" cy="1371600"/>
+            <a:off x="914400" y="457200"/>
+            <a:ext cx="10058400" cy="914400"/>
           </a:xfrm>
           <a:prstGeom prst="rect">
             <a:avLst/>
@@ -4940,14 +5511,14 @@
           <a:lstStyle/>
           <a:p>
             <a:pPr algn="ctr">
-              <a:defRPr sz="8000" b="1">
+              <a:defRPr sz="4400" b="1">
                 <a:solidFill>
                   <a:srgbClr val="86EFAC"/>
                 </a:solidFill>
               </a:defRPr>
             </a:pPr>
             <a:r>
-              <a:t>ZAFE</a:t>
+              <a:t>Roadmap: Médio e Longo Prazo</a:t>
             </a:r>
           </a:p>
         </p:txBody>
@@ -4960,8 +5531,8 @@
         </p:nvSpPr>
         <p:spPr>
           <a:xfrm>
-            <a:off x="914400" y="2286000"/>
-            <a:ext cx="10058400" cy="731520"/>
+            <a:off x="914400" y="1828800"/>
+            <a:ext cx="3200400" cy="457200"/>
           </a:xfrm>
           <a:prstGeom prst="rect">
             <a:avLst/>
@@ -4974,15 +5545,15 @@
           </a:bodyPr>
           <a:lstStyle/>
           <a:p>
-            <a:pPr algn="ctr">
-              <a:defRPr sz="3200" b="0">
-                <a:solidFill>
-                  <a:srgbClr val="FFFFFF"/>
-                </a:solidFill>
-              </a:defRPr>
-            </a:pPr>
-            <a:r>
-              <a:t>A Liga de Previsões do Brasil</a:t>
+            <a:pPr algn="l">
+              <a:defRPr sz="2000" b="1">
+                <a:solidFill>
+                  <a:srgbClr val="86EFAC"/>
+                </a:solidFill>
+              </a:defRPr>
+            </a:pPr>
+            <a:r>
+              <a:t>Médio Prazo (3-6 meses)</a:t>
             </a:r>
           </a:p>
         </p:txBody>
@@ -4995,8 +5566,8 @@
         </p:nvSpPr>
         <p:spPr>
           <a:xfrm>
-            <a:off x="1828800" y="3200400"/>
-            <a:ext cx="8229600" cy="1828800"/>
+            <a:off x="914400" y="2377440"/>
+            <a:ext cx="3474720" cy="1828800"/>
           </a:xfrm>
           <a:prstGeom prst="rect">
             <a:avLst/>
@@ -5009,63 +5580,63 @@
           </a:bodyPr>
           <a:lstStyle/>
           <a:p>
-            <a:pPr algn="ctr">
-              <a:defRPr sz="1800">
-                <a:solidFill>
-                  <a:srgbClr val="FFFFFF"/>
-                </a:solidFill>
-              </a:defRPr>
-            </a:pPr>
-            <a:r>
-              <a:t>• 100% Legal (Lei 5.768/71 + CMN 5.298)</a:t>
-            </a:r>
-          </a:p>
-          <a:p>
-            <a:pPr algn="ctr">
-              <a:defRPr sz="1800">
-                <a:solidFill>
-                  <a:srgbClr val="FFFFFF"/>
-                </a:solidFill>
-              </a:defRPr>
-            </a:pPr>
-            <a:r>
-              <a:t>• Sem apostas, sem depósitos de dinheiro real</a:t>
-            </a:r>
-          </a:p>
-          <a:p>
-            <a:pPr algn="ctr">
-              <a:defRPr sz="1800">
-                <a:solidFill>
-                  <a:srgbClr val="FFFFFF"/>
-                </a:solidFill>
-              </a:defRPr>
-            </a:pPr>
-            <a:r>
-              <a:t>• Prêmios reais no concurso via PIX</a:t>
-            </a:r>
-          </a:p>
-          <a:p>
-            <a:pPr algn="ctr">
-              <a:defRPr sz="1800">
-                <a:solidFill>
-                  <a:srgbClr val="FFFFFF"/>
-                </a:solidFill>
-              </a:defRPr>
-            </a:pPr>
-            <a:r>
-              <a:t>• Tecnologia de ponta (4 camadas de resolução)</a:t>
-            </a:r>
-          </a:p>
-          <a:p>
-            <a:pPr algn="ctr">
-              <a:defRPr sz="1800">
-                <a:solidFill>
-                  <a:srgbClr val="FFFFFF"/>
-                </a:solidFill>
-              </a:defRPr>
-            </a:pPr>
-            <a:r>
-              <a:t>• Zafes: a moeda virtual que vale descontos reais</a:t>
+            <a:pPr algn="l">
+              <a:defRPr sz="1400">
+                <a:solidFill>
+                  <a:srgbClr val="FFFFFF"/>
+                </a:solidFill>
+              </a:defRPr>
+            </a:pPr>
+            <a:r>
+              <a:t>• Zafe Premium (R$ 19,90/mês)</a:t>
+            </a:r>
+          </a:p>
+          <a:p>
+            <a:pPr algn="l">
+              <a:defRPr sz="1400">
+                <a:solidFill>
+                  <a:srgbClr val="FFFFFF"/>
+                </a:solidFill>
+              </a:defRPr>
+            </a:pPr>
+            <a:r>
+              <a:t>• Parcerias de patrocínio corporativo</a:t>
+            </a:r>
+          </a:p>
+          <a:p>
+            <a:pPr algn="l">
+              <a:defRPr sz="1400">
+                <a:solidFill>
+                  <a:srgbClr val="FFFFFF"/>
+                </a:solidFill>
+              </a:defRPr>
+            </a:pPr>
+            <a:r>
+              <a:t>• Concurso Trimestral R$ 25k</a:t>
+            </a:r>
+          </a:p>
+          <a:p>
+            <a:pPr algn="l">
+              <a:defRPr sz="1400">
+                <a:solidFill>
+                  <a:srgbClr val="FFFFFF"/>
+                </a:solidFill>
+              </a:defRPr>
+            </a:pPr>
+            <a:r>
+              <a:t>• Gamificação (badges, níveis, streaks)</a:t>
+            </a:r>
+          </a:p>
+          <a:p>
+            <a:pPr algn="l">
+              <a:defRPr sz="1400">
+                <a:solidFill>
+                  <a:srgbClr val="FFFFFF"/>
+                </a:solidFill>
+              </a:defRPr>
+            </a:pPr>
+            <a:r>
+              <a:t>• Recursos sociais (seguir previsores)</a:t>
             </a:r>
           </a:p>
         </p:txBody>
@@ -5078,8 +5649,8 @@
         </p:nvSpPr>
         <p:spPr>
           <a:xfrm>
-            <a:off x="914400" y="5303520"/>
-            <a:ext cx="10058400" cy="548640"/>
+            <a:off x="4572000" y="1828800"/>
+            <a:ext cx="3200400" cy="457200"/>
           </a:xfrm>
           <a:prstGeom prst="rect">
             <a:avLst/>
@@ -5092,7 +5663,7 @@
           </a:bodyPr>
           <a:lstStyle/>
           <a:p>
-            <a:pPr algn="ctr">
+            <a:pPr algn="l">
               <a:defRPr sz="2000" b="1">
                 <a:solidFill>
                   <a:srgbClr val="86EFAC"/>
@@ -5100,7 +5671,7 @@
               </a:defRPr>
             </a:pPr>
             <a:r>
-              <a:t>Zafe: A liga onde você compete prevendo o que vai acontecer.</a:t>
+              <a:t>Longo Prazo (6-12 meses)</a:t>
             </a:r>
           </a:p>
         </p:txBody>
@@ -5113,8 +5684,8 @@
         </p:nvSpPr>
         <p:spPr>
           <a:xfrm>
-            <a:off x="914400" y="5943600"/>
-            <a:ext cx="10058400" cy="365760"/>
+            <a:off x="4572000" y="2377440"/>
+            <a:ext cx="3474720" cy="1828800"/>
           </a:xfrm>
           <a:prstGeom prst="rect">
             <a:avLst/>
@@ -5127,15 +5698,63 @@
           </a:bodyPr>
           <a:lstStyle/>
           <a:p>
-            <a:pPr algn="ctr">
-              <a:defRPr sz="1600" b="0">
-                <a:solidFill>
-                  <a:srgbClr val="C8C8C8"/>
-                </a:solidFill>
-              </a:defRPr>
-            </a:pPr>
-            <a:r>
-              <a:t>zafe-rho.vercel.app → em breve zafe.com.br</a:t>
+            <a:pPr algn="l">
+              <a:defRPr sz="1400">
+                <a:solidFill>
+                  <a:srgbClr val="FFFFFF"/>
+                </a:solidFill>
+              </a:defRPr>
+            </a:pPr>
+            <a:r>
+              <a:t>• Troca de Zafes: 10.000 Z$ = 10% desconto</a:t>
+            </a:r>
+          </a:p>
+          <a:p>
+            <a:pPr algn="l">
+              <a:defRPr sz="1400">
+                <a:solidFill>
+                  <a:srgbClr val="FFFFFF"/>
+                </a:solidFill>
+              </a:defRPr>
+            </a:pPr>
+            <a:r>
+              <a:t>• Zafes viram moeda de fidelidade</a:t>
+            </a:r>
+          </a:p>
+          <a:p>
+            <a:pPr algn="l">
+              <a:defRPr sz="1400">
+                <a:solidFill>
+                  <a:srgbClr val="FFFFFF"/>
+                </a:solidFill>
+              </a:defRPr>
+            </a:pPr>
+            <a:r>
+              <a:t>• Converter Z$ em descontos reais (parcerias)</a:t>
+            </a:r>
+          </a:p>
+          <a:p>
+            <a:pPr algn="l">
+              <a:defRPr sz="1400">
+                <a:solidFill>
+                  <a:srgbClr val="FFFFFF"/>
+                </a:solidFill>
+              </a:defRPr>
+            </a:pPr>
+            <a:r>
+              <a:t>• Venda de dados B2B (sabedoria das multidões)</a:t>
+            </a:r>
+          </a:p>
+          <a:p>
+            <a:pPr algn="l">
+              <a:defRPr sz="1400">
+                <a:solidFill>
+                  <a:srgbClr val="FFFFFF"/>
+                </a:solidFill>
+              </a:defRPr>
+            </a:pPr>
+            <a:r>
+              <a:t>• Premium escalado nacionalmente</a:t>
             </a:r>
           </a:p>
         </p:txBody>
@@ -5148,8 +5767,8 @@
         </p:nvSpPr>
         <p:spPr>
           <a:xfrm>
-            <a:off x="914400" y="6400800"/>
-            <a:ext cx="10058400" cy="457200"/>
+            <a:off x="8229600" y="1828800"/>
+            <a:ext cx="3200400" cy="457200"/>
           </a:xfrm>
           <a:prstGeom prst="rect">
             <a:avLst/>
@@ -5162,6 +5781,368 @@
           </a:bodyPr>
           <a:lstStyle/>
           <a:p>
+            <a:pPr algn="l">
+              <a:defRPr sz="2000" b="1">
+                <a:solidFill>
+                  <a:srgbClr val="86EFAC"/>
+                </a:solidFill>
+              </a:defRPr>
+            </a:pPr>
+            <a:r>
+              <a:t>Visão de Expansão</a:t>
+            </a:r>
+          </a:p>
+        </p:txBody>
+      </p:sp>
+      <p:sp>
+        <p:nvSpPr>
+          <p:cNvPr id="8" name="TextBox 7"/>
+          <p:cNvSpPr txBox="1"/>
+          <p:nvPr/>
+        </p:nvSpPr>
+        <p:spPr>
+          <a:xfrm>
+            <a:off x="8229600" y="2377440"/>
+            <a:ext cx="3474720" cy="1463040"/>
+          </a:xfrm>
+          <a:prstGeom prst="rect">
+            <a:avLst/>
+          </a:prstGeom>
+          <a:noFill/>
+        </p:spPr>
+        <p:txBody>
+          <a:bodyPr wrap="square">
+            <a:spAutoFit/>
+          </a:bodyPr>
+          <a:lstStyle/>
+          <a:p>
+            <a:pPr algn="l">
+              <a:defRPr sz="1400">
+                <a:solidFill>
+                  <a:srgbClr val="FFFFFF"/>
+                </a:solidFill>
+              </a:defRPr>
+            </a:pPr>
+            <a:r>
+              <a:t>• Consolidação da marca nacionalmente</a:t>
+            </a:r>
+          </a:p>
+          <a:p>
+            <a:pPr algn="l">
+              <a:defRPr sz="1400">
+                <a:solidFill>
+                  <a:srgbClr val="FFFFFF"/>
+                </a:solidFill>
+              </a:defRPr>
+            </a:pPr>
+            <a:r>
+              <a:t>• Liderança em liga de previsões no Brasil</a:t>
+            </a:r>
+          </a:p>
+          <a:p>
+            <a:pPr algn="l">
+              <a:defRPr sz="1400">
+                <a:solidFill>
+                  <a:srgbClr val="FFFFFF"/>
+                </a:solidFill>
+              </a:defRPr>
+            </a:pPr>
+            <a:r>
+              <a:t>• Parcerias com varejistas</a:t>
+            </a:r>
+          </a:p>
+          <a:p>
+            <a:pPr algn="l">
+              <a:defRPr sz="1400">
+                <a:solidFill>
+                  <a:srgbClr val="FFFFFF"/>
+                </a:solidFill>
+              </a:defRPr>
+            </a:pPr>
+            <a:r>
+              <a:t>• Expansão para 100k+ usuários</a:t>
+            </a:r>
+          </a:p>
+        </p:txBody>
+      </p:sp>
+    </p:spTree>
+  </p:cSld>
+  <p:clrMapOvr>
+    <a:masterClrMapping/>
+  </p:clrMapOvr>
+</p:sld>
+</file>
+
+<file path=ppt/slides/slide13.xml><?xml version="1.0" encoding="utf-8"?>
+<p:sld xmlns:a="http://schemas.openxmlformats.org/drawingml/2006/main" xmlns:r="http://schemas.openxmlformats.org/officeDocument/2006/relationships" xmlns:p="http://schemas.openxmlformats.org/presentationml/2006/main">
+  <p:cSld>
+    <p:bg>
+      <p:bgPr>
+        <a:solidFill>
+          <a:srgbClr val="000000"/>
+        </a:solidFill>
+        <a:effectLst/>
+      </p:bgPr>
+    </p:bg>
+    <p:spTree>
+      <p:nvGrpSpPr>
+        <p:cNvPr id="1" name=""/>
+        <p:cNvGrpSpPr/>
+        <p:nvPr/>
+      </p:nvGrpSpPr>
+      <p:grpSpPr>
+        <a:xfrm>
+          <a:off x="0" y="0"/>
+          <a:ext cx="0" cy="0"/>
+          <a:chOff x="0" y="0"/>
+          <a:chExt cx="0" cy="0"/>
+        </a:xfrm>
+      </p:grpSpPr>
+      <p:sp>
+        <p:nvSpPr>
+          <p:cNvPr id="2" name="TextBox 1"/>
+          <p:cNvSpPr txBox="1"/>
+          <p:nvPr/>
+        </p:nvSpPr>
+        <p:spPr>
+          <a:xfrm>
+            <a:off x="914400" y="914400"/>
+            <a:ext cx="10058400" cy="1371600"/>
+          </a:xfrm>
+          <a:prstGeom prst="rect">
+            <a:avLst/>
+          </a:prstGeom>
+          <a:noFill/>
+        </p:spPr>
+        <p:txBody>
+          <a:bodyPr wrap="square">
+            <a:spAutoFit/>
+          </a:bodyPr>
+          <a:lstStyle/>
+          <a:p>
+            <a:pPr algn="ctr">
+              <a:defRPr sz="8000" b="1">
+                <a:solidFill>
+                  <a:srgbClr val="86EFAC"/>
+                </a:solidFill>
+              </a:defRPr>
+            </a:pPr>
+            <a:r>
+              <a:t>ZAFE</a:t>
+            </a:r>
+          </a:p>
+        </p:txBody>
+      </p:sp>
+      <p:sp>
+        <p:nvSpPr>
+          <p:cNvPr id="3" name="TextBox 2"/>
+          <p:cNvSpPr txBox="1"/>
+          <p:nvPr/>
+        </p:nvSpPr>
+        <p:spPr>
+          <a:xfrm>
+            <a:off x="914400" y="2286000"/>
+            <a:ext cx="10058400" cy="731520"/>
+          </a:xfrm>
+          <a:prstGeom prst="rect">
+            <a:avLst/>
+          </a:prstGeom>
+          <a:noFill/>
+        </p:spPr>
+        <p:txBody>
+          <a:bodyPr wrap="square">
+            <a:spAutoFit/>
+          </a:bodyPr>
+          <a:lstStyle/>
+          <a:p>
+            <a:pPr algn="ctr">
+              <a:defRPr sz="3200" b="0">
+                <a:solidFill>
+                  <a:srgbClr val="FFFFFF"/>
+                </a:solidFill>
+              </a:defRPr>
+            </a:pPr>
+            <a:r>
+              <a:t>O Fantasy Game de Previsões do Brasil</a:t>
+            </a:r>
+          </a:p>
+        </p:txBody>
+      </p:sp>
+      <p:sp>
+        <p:nvSpPr>
+          <p:cNvPr id="4" name="TextBox 3"/>
+          <p:cNvSpPr txBox="1"/>
+          <p:nvPr/>
+        </p:nvSpPr>
+        <p:spPr>
+          <a:xfrm>
+            <a:off x="1828800" y="3200400"/>
+            <a:ext cx="8229600" cy="1828800"/>
+          </a:xfrm>
+          <a:prstGeom prst="rect">
+            <a:avLst/>
+          </a:prstGeom>
+          <a:noFill/>
+        </p:spPr>
+        <p:txBody>
+          <a:bodyPr wrap="square">
+            <a:spAutoFit/>
+          </a:bodyPr>
+          <a:lstStyle/>
+          <a:p>
+            <a:pPr algn="ctr">
+              <a:defRPr sz="1800">
+                <a:solidFill>
+                  <a:srgbClr val="FFFFFF"/>
+                </a:solidFill>
+              </a:defRPr>
+            </a:pPr>
+            <a:r>
+              <a:t>• 100% Legal (Lei 5.768/71 + CMN 5.298)</a:t>
+            </a:r>
+          </a:p>
+          <a:p>
+            <a:pPr algn="ctr">
+              <a:defRPr sz="1800">
+                <a:solidFill>
+                  <a:srgbClr val="FFFFFF"/>
+                </a:solidFill>
+              </a:defRPr>
+            </a:pPr>
+            <a:r>
+              <a:t>• Sem apostas, sem depósitos de dinheiro real</a:t>
+            </a:r>
+          </a:p>
+          <a:p>
+            <a:pPr algn="ctr">
+              <a:defRPr sz="1800">
+                <a:solidFill>
+                  <a:srgbClr val="FFFFFF"/>
+                </a:solidFill>
+              </a:defRPr>
+            </a:pPr>
+            <a:r>
+              <a:t>• Prêmios reais no concurso mensal via PIX</a:t>
+            </a:r>
+          </a:p>
+          <a:p>
+            <a:pPr algn="ctr">
+              <a:defRPr sz="1800">
+                <a:solidFill>
+                  <a:srgbClr val="FFFFFF"/>
+                </a:solidFill>
+              </a:defRPr>
+            </a:pPr>
+            <a:r>
+              <a:t>• Tecnologia de ponta (4 camadas de resolução)</a:t>
+            </a:r>
+          </a:p>
+          <a:p>
+            <a:pPr algn="ctr">
+              <a:defRPr sz="1800">
+                <a:solidFill>
+                  <a:srgbClr val="FFFFFF"/>
+                </a:solidFill>
+              </a:defRPr>
+            </a:pPr>
+            <a:r>
+              <a:t>• Z$: moeda virtual sem valor monetário real</a:t>
+            </a:r>
+          </a:p>
+        </p:txBody>
+      </p:sp>
+      <p:sp>
+        <p:nvSpPr>
+          <p:cNvPr id="5" name="TextBox 4"/>
+          <p:cNvSpPr txBox="1"/>
+          <p:nvPr/>
+        </p:nvSpPr>
+        <p:spPr>
+          <a:xfrm>
+            <a:off x="914400" y="5303520"/>
+            <a:ext cx="10058400" cy="548640"/>
+          </a:xfrm>
+          <a:prstGeom prst="rect">
+            <a:avLst/>
+          </a:prstGeom>
+          <a:noFill/>
+        </p:spPr>
+        <p:txBody>
+          <a:bodyPr wrap="square">
+            <a:spAutoFit/>
+          </a:bodyPr>
+          <a:lstStyle/>
+          <a:p>
+            <a:pPr algn="ctr">
+              <a:defRPr sz="2000" b="1">
+                <a:solidFill>
+                  <a:srgbClr val="86EFAC"/>
+                </a:solidFill>
+              </a:defRPr>
+            </a:pPr>
+            <a:r>
+              <a:t>Zafe: A liga onde você compete prevendo o que vai acontecer.</a:t>
+            </a:r>
+          </a:p>
+        </p:txBody>
+      </p:sp>
+      <p:sp>
+        <p:nvSpPr>
+          <p:cNvPr id="6" name="TextBox 5"/>
+          <p:cNvSpPr txBox="1"/>
+          <p:nvPr/>
+        </p:nvSpPr>
+        <p:spPr>
+          <a:xfrm>
+            <a:off x="914400" y="5943600"/>
+            <a:ext cx="10058400" cy="365760"/>
+          </a:xfrm>
+          <a:prstGeom prst="rect">
+            <a:avLst/>
+          </a:prstGeom>
+          <a:noFill/>
+        </p:spPr>
+        <p:txBody>
+          <a:bodyPr wrap="square">
+            <a:spAutoFit/>
+          </a:bodyPr>
+          <a:lstStyle/>
+          <a:p>
+            <a:pPr algn="ctr">
+              <a:defRPr sz="1600" b="0">
+                <a:solidFill>
+                  <a:srgbClr val="C8C8C8"/>
+                </a:solidFill>
+              </a:defRPr>
+            </a:pPr>
+            <a:r>
+              <a:t>zafe-rho.vercel.app → em breve zafe.com.br</a:t>
+            </a:r>
+          </a:p>
+        </p:txBody>
+      </p:sp>
+      <p:sp>
+        <p:nvSpPr>
+          <p:cNvPr id="7" name="TextBox 6"/>
+          <p:cNvSpPr txBox="1"/>
+          <p:nvPr/>
+        </p:nvSpPr>
+        <p:spPr>
+          <a:xfrm>
+            <a:off x="914400" y="6400800"/>
+            <a:ext cx="10058400" cy="457200"/>
+          </a:xfrm>
+          <a:prstGeom prst="rect">
+            <a:avLst/>
+          </a:prstGeom>
+          <a:noFill/>
+        </p:spPr>
+        <p:txBody>
+          <a:bodyPr wrap="square">
+            <a:spAutoFit/>
+          </a:bodyPr>
+          <a:lstStyle/>
+          <a:p>
             <a:pPr algn="ctr">
               <a:defRPr sz="1800" b="1">
                 <a:solidFill>
@@ -5176,6 +6157,11 @@
         </p:txBody>
       </p:sp>
     </p:spTree>
+    <p:extLst>
+      <p:ext uri="{BB962C8B-B14F-4D97-AF65-F5344CB8AC3E}">
+        <p14:creationId xmlns:p14="http://schemas.microsoft.com/office/powerpoint/2010/main" val="183267965"/>
+      </p:ext>
+    </p:extLst>
   </p:cSld>
   <p:clrMapOvr>
     <a:masterClrMapping/>
@@ -5367,7 +6353,7 @@
               </a:defRPr>
             </a:pPr>
             <a:r>
-              <a:t>• Competição de habilidade analítica</a:t>
+              <a:t>• Competição de habilidade preditiva</a:t>
             </a:r>
           </a:p>
           <a:p>
@@ -5379,7 +6365,7 @@
               </a:defRPr>
             </a:pPr>
             <a:r>
-              <a:t>• Moeda virtual: Zafes (não convertível em dinheiro)</a:t>
+              <a:t>• Moeda virtual: Z$ (sem valor monetário real)</a:t>
             </a:r>
           </a:p>
           <a:p>
@@ -5391,7 +6377,7 @@
               </a:defRPr>
             </a:pPr>
             <a:r>
-              <a:t>• Prêmios reais via PIX no concurso</a:t>
+              <a:t>• Prêmios reais via PIX no concurso mensal</a:t>
             </a:r>
           </a:p>
         </p:txBody>
@@ -5515,6 +6501,11 @@
         </p:txBody>
       </p:sp>
     </p:spTree>
+    <p:extLst>
+      <p:ext uri="{BB962C8B-B14F-4D97-AF65-F5344CB8AC3E}">
+        <p14:creationId xmlns:p14="http://schemas.microsoft.com/office/powerpoint/2010/main" val="3400719371"/>
+      </p:ext>
+    </p:extLst>
   </p:cSld>
   <p:clrMapOvr>
     <a:masterClrMapping/>
@@ -5577,7 +6568,7 @@
               </a:defRPr>
             </a:pPr>
             <a:r>
-              <a:t>Por que a Zafe existe?</a:t>
+              <a:t>Estado Atual (Maio/2026)</a:t>
             </a:r>
           </a:p>
         </p:txBody>
@@ -5612,7 +6603,7 @@
               </a:defRPr>
             </a:pPr>
             <a:r>
-              <a:t>O Problema</a:t>
+              <a:t>O que somos hoje</a:t>
             </a:r>
           </a:p>
         </p:txBody>
@@ -5626,7 +6617,7 @@
         <p:spPr>
           <a:xfrm>
             <a:off x="914400" y="2377440"/>
-            <a:ext cx="5029200" cy="2286000"/>
+            <a:ext cx="5029200" cy="1371600"/>
           </a:xfrm>
           <a:prstGeom prst="rect">
             <a:avLst/>
@@ -5647,7 +6638,7 @@
               </a:defRPr>
             </a:pPr>
             <a:r>
-              <a:t>• Brasileiro é proibido de prever eventos esportivos (CMN 5.298/2026)</a:t>
+              <a:t>• Lançamos utilizando Z$ como moeda virtual</a:t>
             </a:r>
           </a:p>
           <a:p>
@@ -5659,7 +6650,7 @@
               </a:defRPr>
             </a:pPr>
             <a:r>
-              <a:t>• Casas de aposta exploram dependência química (dopamina)</a:t>
+              <a:t>• Sistema de resolução em 4 camadas (87% sucesso)</a:t>
             </a:r>
           </a:p>
           <a:p>
@@ -5671,19 +6662,7 @@
               </a:defRPr>
             </a:pPr>
             <a:r>
-              <a:t>• Usuário perde dinheiro real sem hiberitação analítica</a:t>
-            </a:r>
-          </a:p>
-          <a:p>
-            <a:pPr algn="l">
-              <a:defRPr sz="1600">
-                <a:solidFill>
-                  <a:srgbClr val="FFFFFF"/>
-                </a:solidFill>
-              </a:defRPr>
-            </a:pPr>
-            <a:r>
-              <a:t>• Falta de plataforma nacional de competição de previsões</a:t>
+              <a:t>• Eventos reais rodando na Liga e Econômico</a:t>
             </a:r>
           </a:p>
         </p:txBody>
@@ -5696,8 +6675,8 @@
         </p:nvSpPr>
         <p:spPr>
           <a:xfrm>
-            <a:off x="6400800" y="1828800"/>
-            <a:ext cx="4572000" cy="457200"/>
+            <a:off x="914400" y="3840480"/>
+            <a:ext cx="5029200" cy="548640"/>
           </a:xfrm>
           <a:prstGeom prst="rect">
             <a:avLst/>
@@ -5711,14 +6690,14 @@
           <a:lstStyle/>
           <a:p>
             <a:pPr algn="l">
-              <a:defRPr sz="2400" b="1">
-                <a:solidFill>
-                  <a:srgbClr val="86EFAC"/>
-                </a:solidFill>
-              </a:defRPr>
-            </a:pPr>
-            <a:r>
-              <a:t>A Solução Zafe</a:t>
+              <a:defRPr sz="1600" b="1">
+                <a:solidFill>
+                  <a:srgbClr val="EAB308"/>
+                </a:solidFill>
+              </a:defRPr>
+            </a:pPr>
+            <a:r>
+              <a:t>Objetivo Imediato: Alcançar 1.000 usuários ativos na fase de testes.</a:t>
             </a:r>
           </a:p>
         </p:txBody>
@@ -5731,8 +6710,8 @@
         </p:nvSpPr>
         <p:spPr>
           <a:xfrm>
-            <a:off x="6400800" y="2377440"/>
-            <a:ext cx="5029200" cy="2286000"/>
+            <a:off x="6400800" y="1828800"/>
+            <a:ext cx="4572000" cy="457200"/>
           </a:xfrm>
           <a:prstGeom prst="rect">
             <a:avLst/>
@@ -5746,6 +6725,41 @@
           <a:lstStyle/>
           <a:p>
             <a:pPr algn="l">
+              <a:defRPr sz="2400" b="1">
+                <a:solidFill>
+                  <a:srgbClr val="86EFAC"/>
+                </a:solidFill>
+              </a:defRPr>
+            </a:pPr>
+            <a:r>
+              <a:t>O que muda com 1000 usuários</a:t>
+            </a:r>
+          </a:p>
+        </p:txBody>
+      </p:sp>
+      <p:sp>
+        <p:nvSpPr>
+          <p:cNvPr id="7" name="TextBox 6"/>
+          <p:cNvSpPr txBox="1"/>
+          <p:nvPr/>
+        </p:nvSpPr>
+        <p:spPr>
+          <a:xfrm>
+            <a:off x="6400800" y="2377440"/>
+            <a:ext cx="5029200" cy="1828800"/>
+          </a:xfrm>
+          <a:prstGeom prst="rect">
+            <a:avLst/>
+          </a:prstGeom>
+          <a:noFill/>
+        </p:spPr>
+        <p:txBody>
+          <a:bodyPr wrap="square">
+            <a:spAutoFit/>
+          </a:bodyPr>
+          <a:lstStyle/>
+          <a:p>
+            <a:pPr algn="l">
               <a:defRPr sz="1600">
                 <a:solidFill>
                   <a:srgbClr val="FFFFFF"/>
@@ -5753,7 +6767,7 @@
               </a:defRPr>
             </a:pPr>
             <a:r>
-              <a:t>• Posicionamento legal: concurso de previsões (Lei 5.768/71)</a:t>
+              <a:t>• Aumentar volume de palpites na Liga</a:t>
             </a:r>
           </a:p>
           <a:p>
@@ -5765,7 +6779,7 @@
               </a:defRPr>
             </a:pPr>
             <a:r>
-              <a:t>• Sem dinheiro real em jogo (Zafes virtuais)</a:t>
+              <a:t>• Validar modelo de competição social</a:t>
             </a:r>
           </a:p>
           <a:p>
@@ -5777,7 +6791,7 @@
               </a:defRPr>
             </a:pPr>
             <a:r>
-              <a:t>• Foco em habilidade analítica e calibração</a:t>
+              <a:t>• Migrar de beta para lançamento oficial</a:t>
             </a:r>
           </a:p>
           <a:p>
@@ -5789,12 +6803,64 @@
               </a:defRPr>
             </a:pPr>
             <a:r>
-              <a:t>• Curadoria de informação (Premium) via IA</a:t>
+              <a:t>• Concurso mensal com prêmio real R$ 500 via PIX</a:t>
+            </a:r>
+          </a:p>
+          <a:p>
+            <a:pPr algn="l">
+              <a:defRPr sz="1600">
+                <a:solidFill>
+                  <a:srgbClr val="FFFFFF"/>
+                </a:solidFill>
+              </a:defRPr>
+            </a:pPr>
+            <a:r>
+              <a:t>• Atrair patrocinadores corporativos</a:t>
+            </a:r>
+          </a:p>
+        </p:txBody>
+      </p:sp>
+      <p:sp>
+        <p:nvSpPr>
+          <p:cNvPr id="8" name="TextBox 7"/>
+          <p:cNvSpPr txBox="1"/>
+          <p:nvPr/>
+        </p:nvSpPr>
+        <p:spPr>
+          <a:xfrm>
+            <a:off x="914400" y="5669280"/>
+            <a:ext cx="10058400" cy="548640"/>
+          </a:xfrm>
+          <a:prstGeom prst="rect">
+            <a:avLst/>
+          </a:prstGeom>
+          <a:noFill/>
+        </p:spPr>
+        <p:txBody>
+          <a:bodyPr wrap="square">
+            <a:spAutoFit/>
+          </a:bodyPr>
+          <a:lstStyle/>
+          <a:p>
+            <a:pPr algn="ctr">
+              <a:defRPr sz="1800" b="1">
+                <a:solidFill>
+                  <a:srgbClr val="86EFAC"/>
+                </a:solidFill>
+              </a:defRPr>
+            </a:pPr>
+            <a:r>
+              <a:t>Zafes: A moeda virtual que gera prêmios reais através de comprovação de habilidade analítica.</a:t>
             </a:r>
           </a:p>
         </p:txBody>
       </p:sp>
     </p:spTree>
+    <p:extLst>
+      <p:ext uri="{BB962C8B-B14F-4D97-AF65-F5344CB8AC3E}">
+        <p14:creationId xmlns:p14="http://schemas.microsoft.com/office/powerpoint/2010/main" val="1984831906"/>
+      </p:ext>
+    </p:extLst>
   </p:cSld>
   <p:clrMapOvr>
     <a:masterClrMapping/>
@@ -5857,7 +6923,7 @@
               </a:defRPr>
             </a:pPr>
             <a:r>
-              <a:t>Zafe Econômico</a:t>
+              <a:t>Por que a Zafe existe?</a:t>
             </a:r>
           </a:p>
         </p:txBody>
@@ -5870,8 +6936,8 @@
         </p:nvSpPr>
         <p:spPr>
           <a:xfrm>
-            <a:off x="914400" y="1645920"/>
-            <a:ext cx="10058400" cy="548640"/>
+            <a:off x="914400" y="1828800"/>
+            <a:ext cx="4572000" cy="457200"/>
           </a:xfrm>
           <a:prstGeom prst="rect">
             <a:avLst/>
@@ -5884,15 +6950,15 @@
           </a:bodyPr>
           <a:lstStyle/>
           <a:p>
-            <a:pPr algn="ctr">
-              <a:defRPr sz="2000" b="0">
-                <a:solidFill>
-                  <a:srgbClr val="FFFFFF"/>
-                </a:solidFill>
-              </a:defRPr>
-            </a:pPr>
-            <a:r>
-              <a:t>Palpite sobre indicadores econômicos</a:t>
+            <a:pPr algn="l">
+              <a:defRPr sz="2400" b="1">
+                <a:solidFill>
+                  <a:srgbClr val="86EFAC"/>
+                </a:solidFill>
+              </a:defRPr>
+            </a:pPr>
+            <a:r>
+              <a:t>O Problema</a:t>
             </a:r>
           </a:p>
         </p:txBody>
@@ -5906,7 +6972,7 @@
         <p:spPr>
           <a:xfrm>
             <a:off x="914400" y="2377440"/>
-            <a:ext cx="4572000" cy="457200"/>
+            <a:ext cx="5029200" cy="2286000"/>
           </a:xfrm>
           <a:prstGeom prst="rect">
             <a:avLst/>
@@ -5920,14 +6986,50 @@
           <a:lstStyle/>
           <a:p>
             <a:pPr algn="l">
-              <a:defRPr sz="2400" b="1">
-                <a:solidFill>
-                  <a:srgbClr val="86EFAC"/>
-                </a:solidFill>
-              </a:defRPr>
-            </a:pPr>
-            <a:r>
-              <a:t>Como Funciona</a:t>
+              <a:defRPr sz="1600">
+                <a:solidFill>
+                  <a:srgbClr val="FFFFFF"/>
+                </a:solidFill>
+              </a:defRPr>
+            </a:pPr>
+            <a:r>
+              <a:t>• Brasileiro é proibido de prever eventos esportivos (CMN 5.298/2026)</a:t>
+            </a:r>
+          </a:p>
+          <a:p>
+            <a:pPr algn="l">
+              <a:defRPr sz="1600">
+                <a:solidFill>
+                  <a:srgbClr val="FFFFFF"/>
+                </a:solidFill>
+              </a:defRPr>
+            </a:pPr>
+            <a:r>
+              <a:t>• Casas de aposta exploram dependência química (dopamina)</a:t>
+            </a:r>
+          </a:p>
+          <a:p>
+            <a:pPr algn="l">
+              <a:defRPr sz="1600">
+                <a:solidFill>
+                  <a:srgbClr val="FFFFFF"/>
+                </a:solidFill>
+              </a:defRPr>
+            </a:pPr>
+            <a:r>
+              <a:t>• Usuário perde dinheiro real sem hiberitação analítica</a:t>
+            </a:r>
+          </a:p>
+          <a:p>
+            <a:pPr algn="l">
+              <a:defRPr sz="1600">
+                <a:solidFill>
+                  <a:srgbClr val="FFFFFF"/>
+                </a:solidFill>
+              </a:defRPr>
+            </a:pPr>
+            <a:r>
+              <a:t>• Falta de plataforma nacional de competição de previsões</a:t>
             </a:r>
           </a:p>
         </p:txBody>
@@ -5940,8 +7042,8 @@
         </p:nvSpPr>
         <p:spPr>
           <a:xfrm>
-            <a:off x="914400" y="2926080"/>
-            <a:ext cx="5029200" cy="1828800"/>
+            <a:off x="6400800" y="1828800"/>
+            <a:ext cx="4572000" cy="457200"/>
           </a:xfrm>
           <a:prstGeom prst="rect">
             <a:avLst/>
@@ -5955,50 +7057,14 @@
           <a:lstStyle/>
           <a:p>
             <a:pPr algn="l">
-              <a:defRPr sz="1600">
-                <a:solidFill>
-                  <a:srgbClr val="FFFFFF"/>
-                </a:solidFill>
-              </a:defRPr>
-            </a:pPr>
-            <a:r>
-              <a:t>• Criação: Apenas admin/sistema (não usuários)</a:t>
-            </a:r>
-          </a:p>
-          <a:p>
-            <a:pPr algn="l">
-              <a:defRPr sz="1600">
-                <a:solidFill>
-                  <a:srgbClr val="FFFFFF"/>
-                </a:solidFill>
-              </a:defRPr>
-            </a:pPr>
-            <a:r>
-              <a:t>• Moeda: Z$ Virtual (não convertível em dinheiro real)</a:t>
-            </a:r>
-          </a:p>
-          <a:p>
-            <a:pPr algn="l">
-              <a:defRPr sz="1600">
-                <a:solidFill>
-                  <a:srgbClr val="FFFFFF"/>
-                </a:solidFill>
-              </a:defRPr>
-            </a:pPr>
-            <a:r>
-              <a:t>• Eventos: Selic, IPCA, Dólar, Bitcoin, Ibovespa</a:t>
-            </a:r>
-          </a:p>
-          <a:p>
-            <a:pPr algn="l">
-              <a:defRPr sz="1600">
-                <a:solidFill>
-                  <a:srgbClr val="FFFFFF"/>
-                </a:solidFill>
-              </a:defRPr>
-            </a:pPr>
-            <a:r>
-              <a:t>• Mercado Secundário: Order book com matching FIFO</a:t>
+              <a:defRPr sz="2400" b="1">
+                <a:solidFill>
+                  <a:srgbClr val="86EFAC"/>
+                </a:solidFill>
+              </a:defRPr>
+            </a:pPr>
+            <a:r>
+              <a:t>A Solução Zafe</a:t>
             </a:r>
           </a:p>
         </p:txBody>
@@ -6012,7 +7078,7 @@
         <p:spPr>
           <a:xfrm>
             <a:off x="6400800" y="2377440"/>
-            <a:ext cx="4572000" cy="457200"/>
+            <a:ext cx="5029200" cy="2286000"/>
           </a:xfrm>
           <a:prstGeom prst="rect">
             <a:avLst/>
@@ -6026,28 +7092,70 @@
           <a:lstStyle/>
           <a:p>
             <a:pPr algn="l">
-              <a:defRPr sz="2400" b="1">
-                <a:solidFill>
-                  <a:srgbClr val="86EFAC"/>
-                </a:solidFill>
-              </a:defRPr>
-            </a:pPr>
-            <a:r>
-              <a:t>Categorias Permitidas</a:t>
-            </a:r>
-          </a:p>
-        </p:txBody>
-      </p:sp>
-      <p:sp>
-        <p:nvSpPr>
-          <p:cNvPr id="7" name="TextBox 6"/>
+              <a:defRPr sz="1600">
+                <a:solidFill>
+                  <a:srgbClr val="FFFFFF"/>
+                </a:solidFill>
+              </a:defRPr>
+            </a:pPr>
+            <a:r>
+              <a:t>• Posicionamento legal: concurso de previsões (Lei 5.768/71)</a:t>
+            </a:r>
+          </a:p>
+          <a:p>
+            <a:pPr algn="l">
+              <a:defRPr sz="1600">
+                <a:solidFill>
+                  <a:srgbClr val="FFFFFF"/>
+                </a:solidFill>
+              </a:defRPr>
+            </a:pPr>
+            <a:r>
+              <a:t>• Sem dinheiro real em jogo (Zafes virtuais)</a:t>
+            </a:r>
+          </a:p>
+          <a:p>
+            <a:pPr algn="l">
+              <a:defRPr sz="1600">
+                <a:solidFill>
+                  <a:srgbClr val="FFFFFF"/>
+                </a:solidFill>
+              </a:defRPr>
+            </a:pPr>
+            <a:r>
+              <a:t>• Foco em habilidade analítica e calibração</a:t>
+            </a:r>
+          </a:p>
+          <a:p>
+            <a:pPr algn="l">
+              <a:defRPr sz="1600">
+                <a:solidFill>
+                  <a:srgbClr val="FFFFFF"/>
+                </a:solidFill>
+              </a:defRPr>
+            </a:pPr>
+            <a:r>
+              <a:t>• Curadoria de informação (Premium) via IA</a:t>
+            </a:r>
+          </a:p>
+        </p:txBody>
+      </p:sp>
+      <p:sp>
+        <p:nvSpPr>
+          <p:cNvPr id="7" name="CaixaDeTexto 6">
+            <a:extLst>
+              <a:ext uri="{FF2B5EF4-FFF2-40B4-BE49-F238E27FC236}">
+                <a16:creationId xmlns:a16="http://schemas.microsoft.com/office/drawing/2014/main" id="{17B04DDE-9E5B-C642-B4F0-5D891B8813A1}"/>
+              </a:ext>
+            </a:extLst>
+          </p:cNvPr>
           <p:cNvSpPr txBox="1"/>
           <p:nvPr/>
         </p:nvSpPr>
         <p:spPr>
           <a:xfrm>
-            <a:off x="6400800" y="2926080"/>
-            <a:ext cx="5029200" cy="1828800"/>
+            <a:off x="914400" y="5080000"/>
+            <a:ext cx="10058400" cy="707886"/>
           </a:xfrm>
           <a:prstGeom prst="rect">
             <a:avLst/>
@@ -6055,61 +7163,148 @@
           <a:noFill/>
         </p:spPr>
         <p:txBody>
-          <a:bodyPr wrap="square">
+          <a:bodyPr vertOverflow="overflow" vert="horz" wrap="square" rtlCol="0" anchor="t">
             <a:spAutoFit/>
           </a:bodyPr>
           <a:lstStyle/>
           <a:p>
-            <a:pPr algn="l">
-              <a:defRPr sz="1600">
-                <a:solidFill>
-                  <a:srgbClr val="FFFFFF"/>
-                </a:solidFill>
-              </a:defRPr>
-            </a:pPr>
-            <a:r>
-              <a:t>• Macro Brasil: Selic, IPCA, PIB, desemprego</a:t>
-            </a:r>
-          </a:p>
-          <a:p>
-            <a:pPr algn="l">
-              <a:defRPr sz="1600">
-                <a:solidFill>
-                  <a:srgbClr val="FFFFFF"/>
-                </a:solidFill>
-              </a:defRPr>
-            </a:pPr>
-            <a:r>
-              <a:t>• Mercados: Ibovespa, Dólar, Euro, Ouro</a:t>
-            </a:r>
-          </a:p>
-          <a:p>
-            <a:pPr algn="l">
-              <a:defRPr sz="1600">
-                <a:solidFill>
-                  <a:srgbClr val="FFFFFF"/>
-                </a:solidFill>
-              </a:defRPr>
-            </a:pPr>
-            <a:r>
-              <a:t>• Cripto: Bitcoin, Ethereum (janelas curtas)</a:t>
-            </a:r>
-          </a:p>
-          <a:p>
-            <a:pPr algn="l">
-              <a:defRPr sz="1600">
-                <a:solidFill>
-                  <a:srgbClr val="FFFFFF"/>
-                </a:solidFill>
-              </a:defRPr>
-            </a:pPr>
-            <a:r>
-              <a:t>• Indicadores Globais: Fed, BCE, CPI americano</a:t>
+            <a:pPr algn="ctr">
+              <a:defRPr sz="2000" b="1">
+                <a:solidFill>
+                  <a:srgbClr val="86EFAC"/>
+                </a:solidFill>
+              </a:defRPr>
+            </a:pPr>
+            <a:r>
+              <a:rPr dirty="0" err="1"/>
+              <a:t>Oportunidade</a:t>
+            </a:r>
+            <a:r>
+              <a:rPr dirty="0"/>
+              <a:t> </a:t>
+            </a:r>
+            <a:r>
+              <a:rPr dirty="0" err="1"/>
+              <a:t>única</a:t>
+            </a:r>
+            <a:r>
+              <a:rPr dirty="0"/>
+              <a:t>: </a:t>
+            </a:r>
+            <a:r>
+              <a:rPr dirty="0" err="1"/>
+              <a:t>não</a:t>
+            </a:r>
+            <a:r>
+              <a:rPr dirty="0"/>
+              <a:t> </a:t>
+            </a:r>
+            <a:r>
+              <a:rPr dirty="0" err="1"/>
+              <a:t>existe</a:t>
+            </a:r>
+            <a:r>
+              <a:rPr dirty="0"/>
+              <a:t> mercado </a:t>
+            </a:r>
+            <a:r>
+              <a:rPr dirty="0" err="1"/>
+              <a:t>preditivo</a:t>
+            </a:r>
+            <a:r>
+              <a:rPr dirty="0"/>
+              <a:t> </a:t>
+            </a:r>
+            <a:r>
+              <a:rPr dirty="0" err="1"/>
+              <a:t>nem</a:t>
+            </a:r>
+            <a:r>
+              <a:rPr dirty="0"/>
+              <a:t> cassino no </a:t>
+            </a:r>
+            <a:r>
+              <a:rPr dirty="0" err="1"/>
+              <a:t>Brasil</a:t>
+            </a:r>
+            <a:r>
+              <a:rPr dirty="0"/>
+              <a:t>.</a:t>
+            </a:r>
+          </a:p>
+          <a:p>
+            <a:pPr algn="ctr">
+              <a:defRPr sz="2000" b="1">
+                <a:solidFill>
+                  <a:srgbClr val="86EFAC"/>
+                </a:solidFill>
+              </a:defRPr>
+            </a:pPr>
+            <a:r>
+              <a:rPr dirty="0"/>
+              <a:t>A </a:t>
+            </a:r>
+            <a:r>
+              <a:rPr dirty="0" err="1"/>
+              <a:t>Zafe</a:t>
+            </a:r>
+            <a:r>
+              <a:rPr dirty="0"/>
+              <a:t> </a:t>
+            </a:r>
+            <a:r>
+              <a:rPr dirty="0" err="1"/>
+              <a:t>pode</a:t>
+            </a:r>
+            <a:r>
+              <a:rPr dirty="0"/>
+              <a:t> ser a </a:t>
+            </a:r>
+            <a:r>
+              <a:rPr dirty="0" err="1"/>
+              <a:t>primeira</a:t>
+            </a:r>
+            <a:r>
+              <a:rPr dirty="0"/>
+              <a:t> e </a:t>
+            </a:r>
+            <a:r>
+              <a:rPr dirty="0" err="1"/>
+              <a:t>única</a:t>
+            </a:r>
+            <a:r>
+              <a:rPr dirty="0"/>
+              <a:t> </a:t>
+            </a:r>
+            <a:r>
+              <a:rPr dirty="0" err="1"/>
+              <a:t>empresa</a:t>
+            </a:r>
+            <a:r>
+              <a:rPr dirty="0"/>
+              <a:t> do </a:t>
+            </a:r>
+            <a:r>
+              <a:rPr dirty="0" err="1"/>
+              <a:t>setor</a:t>
+            </a:r>
+            <a:r>
+              <a:rPr lang="pt-BR" dirty="0"/>
+              <a:t>,completamente dentro da lei</a:t>
+            </a:r>
+            <a:r>
+              <a:rPr dirty="0"/>
+              <a:t>.</a:t>
             </a:r>
           </a:p>
         </p:txBody>
       </p:sp>
     </p:spTree>
+    <p:extLst>
+      <p:ext uri="{BB962C8B-B14F-4D97-AF65-F5344CB8AC3E}">
+        <p14:creationId xmlns:p14="http://schemas.microsoft.com/office/powerpoint/2010/main" val="1025524165"/>
+      </p:ext>
+    </p:extLst>
   </p:cSld>
   <p:clrMapOvr>
     <a:masterClrMapping/>
@@ -6151,7 +7346,7 @@
         <p:spPr>
           <a:xfrm>
             <a:off x="914400" y="457200"/>
-            <a:ext cx="10058400" cy="769441"/>
+            <a:ext cx="10058400" cy="914400"/>
           </a:xfrm>
           <a:prstGeom prst="rect">
             <a:avLst/>
@@ -6172,12 +7367,7 @@
               </a:defRPr>
             </a:pPr>
             <a:r>
-              <a:rPr dirty="0" err="1"/>
-              <a:t>Zafe</a:t>
-            </a:r>
-            <a:r>
-              <a:rPr dirty="0"/>
-              <a:t> Liga </a:t>
+              <a:t>Zafe Econômico</a:t>
             </a:r>
           </a:p>
         </p:txBody>
@@ -6191,7 +7381,7 @@
         <p:spPr>
           <a:xfrm>
             <a:off x="914400" y="1645920"/>
-            <a:ext cx="10058400" cy="548640"/>
+            <a:ext cx="10058400" cy="400110"/>
           </a:xfrm>
           <a:prstGeom prst="rect">
             <a:avLst/>
@@ -6212,7 +7402,7 @@
               </a:defRPr>
             </a:pPr>
             <a:r>
-              <a:t>A liga onde você compete prevendo o que vai acontecer</a:t>
+              <a:t>Indicadores econômicos: IPCA, Selic, PIB e mais</a:t>
             </a:r>
           </a:p>
         </p:txBody>
@@ -6282,7 +7472,7 @@
               </a:defRPr>
             </a:pPr>
             <a:r>
-              <a:t>• Criação: Usuários e Admin (aprovação necessária)</a:t>
+              <a:t>• Criação: Apenas admin/sistema (não usuários)</a:t>
             </a:r>
           </a:p>
           <a:p>
@@ -6294,7 +7484,7 @@
               </a:defRPr>
             </a:pPr>
             <a:r>
-              <a:t>• Moeda: Z$ Virtual (mesma da Liga e Privadas)</a:t>
+              <a:t>• Moeda: Z$ Virtual (não convertível em dinheiro real)</a:t>
             </a:r>
           </a:p>
           <a:p>
@@ -6306,7 +7496,7 @@
               </a:defRPr>
             </a:pPr>
             <a:r>
-              <a:t>• Universo: Esporte, Política, BBB, Oscar, Tecnologia</a:t>
+              <a:t>• Eventos: Selic, IPCA, Dólar, Bitcoin, Ibovespa</a:t>
             </a:r>
           </a:p>
           <a:p>
@@ -6318,7 +7508,7 @@
               </a:defRPr>
             </a:pPr>
             <a:r>
-              <a:t>• Banner do Concurso ativo com inscrição grátis</a:t>
+              <a:t>• Mercado Secundário: Order book com matching FIFO</a:t>
             </a:r>
           </a:p>
         </p:txBody>
@@ -6353,7 +7543,7 @@
               </a:defRPr>
             </a:pPr>
             <a:r>
-              <a:t>Diferenciais</a:t>
+              <a:t>Categorias Permitidas</a:t>
             </a:r>
           </a:p>
         </p:txBody>
@@ -6388,7 +7578,7 @@
               </a:defRPr>
             </a:pPr>
             <a:r>
-              <a:t>• Ranking por Brier Score (acurácia agregada)</a:t>
+              <a:t>• Macro Brasil: Selic, IPCA, PIB, desemprego</a:t>
             </a:r>
           </a:p>
           <a:p>
@@ -6400,7 +7590,7 @@
               </a:defRPr>
             </a:pPr>
             <a:r>
-              <a:t>• Mínimo 30 previsões/mês para qualificação</a:t>
+              <a:t>• Mercados: Ibovespa, Dólar, Euro, Ouro</a:t>
             </a:r>
           </a:p>
           <a:p>
@@ -6412,7 +7602,7 @@
               </a:defRPr>
             </a:pPr>
             <a:r>
-              <a:t>• Diversidade: pelo menos 3 categorias diferentes</a:t>
+              <a:t>• Cripto: Bitcoin, Ethereum (janelas curtas)</a:t>
             </a:r>
           </a:p>
           <a:p>
@@ -6424,12 +7614,17 @@
               </a:defRPr>
             </a:pPr>
             <a:r>
-              <a:t>• Trending Feed: eventos em alta (+Z$ / 2h)</a:t>
+              <a:t>• Indicadores Globais: Fed, BCE, CPI americano</a:t>
             </a:r>
           </a:p>
         </p:txBody>
       </p:sp>
     </p:spTree>
+    <p:extLst>
+      <p:ext uri="{BB962C8B-B14F-4D97-AF65-F5344CB8AC3E}">
+        <p14:creationId xmlns:p14="http://schemas.microsoft.com/office/powerpoint/2010/main" val="2456743183"/>
+      </p:ext>
+    </p:extLst>
   </p:cSld>
   <p:clrMapOvr>
     <a:masterClrMapping/>
@@ -6471,7 +7666,7 @@
         <p:spPr>
           <a:xfrm>
             <a:off x="914400" y="457200"/>
-            <a:ext cx="10058400" cy="914400"/>
+            <a:ext cx="10058400" cy="769441"/>
           </a:xfrm>
           <a:prstGeom prst="rect">
             <a:avLst/>
@@ -6492,7 +7687,12 @@
               </a:defRPr>
             </a:pPr>
             <a:r>
-              <a:t>Concurso (Sobreposto à Liga)</a:t>
+              <a:rPr dirty="0" err="1"/>
+              <a:t>Zafe</a:t>
+            </a:r>
+            <a:r>
+              <a:rPr dirty="0"/>
+              <a:t> Liga </a:t>
             </a:r>
           </a:p>
         </p:txBody>
@@ -6505,8 +7705,8 @@
         </p:nvSpPr>
         <p:spPr>
           <a:xfrm>
-            <a:off x="914400" y="1828800"/>
-            <a:ext cx="4572000" cy="457200"/>
+            <a:off x="914400" y="1645920"/>
+            <a:ext cx="10058400" cy="548640"/>
           </a:xfrm>
           <a:prstGeom prst="rect">
             <a:avLst/>
@@ -6519,15 +7719,15 @@
           </a:bodyPr>
           <a:lstStyle/>
           <a:p>
-            <a:pPr algn="l">
-              <a:defRPr sz="2400" b="1">
-                <a:solidFill>
-                  <a:srgbClr val="86EFAC"/>
-                </a:solidFill>
-              </a:defRPr>
-            </a:pPr>
-            <a:r>
-              <a:t>Como Funciona</a:t>
+            <a:pPr algn="ctr">
+              <a:defRPr sz="2000" b="0">
+                <a:solidFill>
+                  <a:srgbClr val="FFFFFF"/>
+                </a:solidFill>
+              </a:defRPr>
+            </a:pPr>
+            <a:r>
+              <a:t>Faça seus palpites e suba no ranking</a:t>
             </a:r>
           </a:p>
         </p:txBody>
@@ -6541,7 +7741,7 @@
         <p:spPr>
           <a:xfrm>
             <a:off x="914400" y="2377440"/>
-            <a:ext cx="5029200" cy="2286000"/>
+            <a:ext cx="4572000" cy="457200"/>
           </a:xfrm>
           <a:prstGeom prst="rect">
             <a:avLst/>
@@ -6555,62 +7755,14 @@
           <a:lstStyle/>
           <a:p>
             <a:pPr algn="l">
-              <a:defRPr sz="1600">
-                <a:solidFill>
-                  <a:srgbClr val="FFFFFF"/>
-                </a:solidFill>
-              </a:defRPr>
-            </a:pPr>
-            <a:r>
-              <a:t>• Inscrição: Gratuita na fase beta (futuramente R$ 9,90)</a:t>
-            </a:r>
-          </a:p>
-          <a:p>
-            <a:pPr algn="l">
-              <a:defRPr sz="1600">
-                <a:solidFill>
-                  <a:srgbClr val="FFFFFF"/>
-                </a:solidFill>
-              </a:defRPr>
-            </a:pPr>
-            <a:r>
-              <a:t>• Critério: Maior acurácia agregada (Brier Score)</a:t>
-            </a:r>
-          </a:p>
-          <a:p>
-            <a:pPr algn="l">
-              <a:defRPr sz="1600">
-                <a:solidFill>
-                  <a:srgbClr val="FFFFFF"/>
-                </a:solidFill>
-              </a:defRPr>
-            </a:pPr>
-            <a:r>
-              <a:t>• Diversidade: Previsões em pelo menos 3 categorias</a:t>
-            </a:r>
-          </a:p>
-          <a:p>
-            <a:pPr algn="l">
-              <a:defRPr sz="1600">
-                <a:solidFill>
-                  <a:srgbClr val="FFFFFF"/>
-                </a:solidFill>
-              </a:defRPr>
-            </a:pPr>
-            <a:r>
-              <a:t>• Prêmio: R$ 2.500 totais distribuídos via PIX</a:t>
-            </a:r>
-          </a:p>
-          <a:p>
-            <a:pPr algn="l">
-              <a:defRPr sz="1600">
-                <a:solidFill>
-                  <a:srgbClr val="FFFFFF"/>
-                </a:solidFill>
-              </a:defRPr>
-            </a:pPr>
-            <a:r>
-              <a:t>• Recurso: Patrocínio de marcas (Coca-Cola, bancos)</a:t>
+              <a:defRPr sz="2400" b="1">
+                <a:solidFill>
+                  <a:srgbClr val="86EFAC"/>
+                </a:solidFill>
+              </a:defRPr>
+            </a:pPr>
+            <a:r>
+              <a:t>Como Funciona</a:t>
             </a:r>
           </a:p>
         </p:txBody>
@@ -6623,8 +7775,8 @@
         </p:nvSpPr>
         <p:spPr>
           <a:xfrm>
-            <a:off x="914400" y="4754880"/>
-            <a:ext cx="4572000" cy="365760"/>
+            <a:off x="914400" y="2926080"/>
+            <a:ext cx="5029200" cy="1828800"/>
           </a:xfrm>
           <a:prstGeom prst="rect">
             <a:avLst/>
@@ -6638,14 +7790,50 @@
           <a:lstStyle/>
           <a:p>
             <a:pPr algn="l">
-              <a:defRPr sz="1800" b="1">
-                <a:solidFill>
-                  <a:srgbClr val="86EFAC"/>
-                </a:solidFill>
-              </a:defRPr>
-            </a:pPr>
-            <a:r>
-              <a:t>Distribuição de Prêmios:</a:t>
+              <a:defRPr sz="1600">
+                <a:solidFill>
+                  <a:srgbClr val="FFFFFF"/>
+                </a:solidFill>
+              </a:defRPr>
+            </a:pPr>
+            <a:r>
+              <a:t>• Criação: Usuários e Admin (aprovação necessária)</a:t>
+            </a:r>
+          </a:p>
+          <a:p>
+            <a:pPr algn="l">
+              <a:defRPr sz="1600">
+                <a:solidFill>
+                  <a:srgbClr val="FFFFFF"/>
+                </a:solidFill>
+              </a:defRPr>
+            </a:pPr>
+            <a:r>
+              <a:t>• Moeda: Z$ Virtual (mesma da Liga e Privadas)</a:t>
+            </a:r>
+          </a:p>
+          <a:p>
+            <a:pPr algn="l">
+              <a:defRPr sz="1600">
+                <a:solidFill>
+                  <a:srgbClr val="FFFFFF"/>
+                </a:solidFill>
+              </a:defRPr>
+            </a:pPr>
+            <a:r>
+              <a:t>• Categorias: Política, Esportes, Cultura, Tecnologia, Entretenimento, Outros</a:t>
+            </a:r>
+          </a:p>
+          <a:p>
+            <a:pPr algn="l">
+              <a:defRPr sz="1600">
+                <a:solidFill>
+                  <a:srgbClr val="FFFFFF"/>
+                </a:solidFill>
+              </a:defRPr>
+            </a:pPr>
+            <a:r>
+              <a:t>• Banner do Concurso Mensal ativo com inscrição grátis</a:t>
             </a:r>
           </a:p>
         </p:txBody>
@@ -6658,8 +7846,8 @@
         </p:nvSpPr>
         <p:spPr>
           <a:xfrm>
-            <a:off x="914400" y="5120640"/>
-            <a:ext cx="5029200" cy="914400"/>
+            <a:off x="6400800" y="2377440"/>
+            <a:ext cx="4572000" cy="457200"/>
           </a:xfrm>
           <a:prstGeom prst="rect">
             <a:avLst/>
@@ -6673,26 +7861,14 @@
           <a:lstStyle/>
           <a:p>
             <a:pPr algn="l">
-              <a:defRPr sz="1400">
-                <a:solidFill>
-                  <a:srgbClr val="C8C8C8"/>
-                </a:solidFill>
-              </a:defRPr>
-            </a:pPr>
-            <a:r>
-              <a:t>1º lugar: R$ 1.000 | 2º lugar: R$ 500 | 3º lugar: R$ 250</a:t>
-            </a:r>
-          </a:p>
-          <a:p>
-            <a:pPr algn="l">
-              <a:defRPr sz="1400">
-                <a:solidFill>
-                  <a:srgbClr val="C8C8C8"/>
-                </a:solidFill>
-              </a:defRPr>
-            </a:pPr>
-            <a:r>
-              <a:t>4º a 10º lugar: R$ 100 cada | 11º a 25º lugar: R$ 35 cada</a:t>
+              <a:defRPr sz="2400" b="1">
+                <a:solidFill>
+                  <a:srgbClr val="86EFAC"/>
+                </a:solidFill>
+              </a:defRPr>
+            </a:pPr>
+            <a:r>
+              <a:t>Diferenciais</a:t>
             </a:r>
           </a:p>
         </p:txBody>
@@ -6705,8 +7881,8 @@
         </p:nvSpPr>
         <p:spPr>
           <a:xfrm>
-            <a:off x="6400800" y="1828800"/>
-            <a:ext cx="4572000" cy="457200"/>
+            <a:off x="6400800" y="2926080"/>
+            <a:ext cx="5029200" cy="1828800"/>
           </a:xfrm>
           <a:prstGeom prst="rect">
             <a:avLst/>
@@ -6720,159 +7896,60 @@
           <a:lstStyle/>
           <a:p>
             <a:pPr algn="l">
-              <a:defRPr sz="2400" b="1">
-                <a:solidFill>
-                  <a:srgbClr val="86EFAC"/>
-                </a:solidFill>
-              </a:defRPr>
-            </a:pPr>
-            <a:r>
-              <a:t>Base Legal (Lei 5.768/71)</a:t>
-            </a:r>
-          </a:p>
-        </p:txBody>
-      </p:sp>
-      <p:sp>
-        <p:nvSpPr>
-          <p:cNvPr id="8" name="TextBox 7"/>
-          <p:cNvSpPr txBox="1"/>
-          <p:nvPr/>
-        </p:nvSpPr>
-        <p:spPr>
-          <a:xfrm>
-            <a:off x="6400800" y="2377440"/>
-            <a:ext cx="5029200" cy="731520"/>
-          </a:xfrm>
-          <a:prstGeom prst="rect">
-            <a:avLst/>
-          </a:prstGeom>
-          <a:noFill/>
-        </p:spPr>
-        <p:txBody>
-          <a:bodyPr wrap="square">
-            <a:spAutoFit/>
-          </a:bodyPr>
-          <a:lstStyle/>
-          <a:p>
-            <a:pPr algn="l">
-              <a:defRPr sz="1400" b="0">
-                <a:solidFill>
-                  <a:srgbClr val="FFFFFF"/>
-                </a:solidFill>
-              </a:defRPr>
-            </a:pPr>
-            <a:r>
-              <a:t>Art. 1º: Concurso de previsões exige autorização SECAP apenas se prêmios &gt; 10% do valor arrecadado.</a:t>
-            </a:r>
-          </a:p>
-        </p:txBody>
-      </p:sp>
-      <p:sp>
-        <p:nvSpPr>
-          <p:cNvPr id="9" name="TextBox 8"/>
-          <p:cNvSpPr txBox="1"/>
-          <p:nvPr/>
-        </p:nvSpPr>
-        <p:spPr>
-          <a:xfrm>
-            <a:off x="6400800" y="3200400"/>
-            <a:ext cx="4572000" cy="365760"/>
-          </a:xfrm>
-          <a:prstGeom prst="rect">
-            <a:avLst/>
-          </a:prstGeom>
-          <a:noFill/>
-        </p:spPr>
-        <p:txBody>
-          <a:bodyPr wrap="square">
-            <a:spAutoFit/>
-          </a:bodyPr>
-          <a:lstStyle/>
-          <a:p>
-            <a:pPr algn="l">
-              <a:defRPr sz="1800" b="1">
-                <a:solidFill>
-                  <a:srgbClr val="86EFAC"/>
-                </a:solidFill>
-              </a:defRPr>
-            </a:pPr>
-            <a:r>
-              <a:t>Dispensa SECAP</a:t>
-            </a:r>
-          </a:p>
-        </p:txBody>
-      </p:sp>
-      <p:sp>
-        <p:nvSpPr>
-          <p:cNvPr id="10" name="TextBox 9"/>
-          <p:cNvSpPr txBox="1"/>
-          <p:nvPr/>
-        </p:nvSpPr>
-        <p:spPr>
-          <a:xfrm>
-            <a:off x="6400800" y="3657600"/>
-            <a:ext cx="5029200" cy="914400"/>
-          </a:xfrm>
-          <a:prstGeom prst="rect">
-            <a:avLst/>
-          </a:prstGeom>
-          <a:noFill/>
-        </p:spPr>
-        <p:txBody>
-          <a:bodyPr wrap="square">
-            <a:spAutoFit/>
-          </a:bodyPr>
-          <a:lstStyle/>
-          <a:p>
-            <a:pPr algn="l">
-              <a:defRPr sz="1400" b="0">
-                <a:solidFill>
-                  <a:srgbClr val="FFFFFF"/>
-                </a:solidFill>
-              </a:defRPr>
-            </a:pPr>
-            <a:r>
-              <a:t>Concurso regular (R$ 2.500) tem patrocínio que cobre prêmios. Não há arrecadação líquida da Zafe, dispensando autorização.</a:t>
-            </a:r>
-          </a:p>
-        </p:txBody>
-      </p:sp>
-      <p:sp>
-        <p:nvSpPr>
-          <p:cNvPr id="11" name="TextBox 10"/>
-          <p:cNvSpPr txBox="1"/>
-          <p:nvPr/>
-        </p:nvSpPr>
-        <p:spPr>
-          <a:xfrm>
-            <a:off x="6400800" y="4754880"/>
-            <a:ext cx="5029200" cy="914400"/>
-          </a:xfrm>
-          <a:prstGeom prst="rect">
-            <a:avLst/>
-          </a:prstGeom>
-          <a:noFill/>
-        </p:spPr>
-        <p:txBody>
-          <a:bodyPr wrap="square">
-            <a:spAutoFit/>
-          </a:bodyPr>
-          <a:lstStyle/>
-          <a:p>
-            <a:pPr algn="l">
-              <a:defRPr sz="1400" b="0">
-                <a:solidFill>
-                  <a:srgbClr val="EAB308"/>
-                </a:solidFill>
-              </a:defRPr>
-            </a:pPr>
-            <a:r>
-              <a:t>Concurso Major: Trimestral R$ 10k-25k. Exige processo formal na SECAP, custo de 10% pago pelo patrocinador.</a:t>
+              <a:defRPr sz="1600">
+                <a:solidFill>
+                  <a:srgbClr val="FFFFFF"/>
+                </a:solidFill>
+              </a:defRPr>
+            </a:pPr>
+            <a:r>
+              <a:t>• Ranking por lucro líquido (Z$)</a:t>
+            </a:r>
+          </a:p>
+          <a:p>
+            <a:pPr algn="l">
+              <a:defRPr sz="1600">
+                <a:solidFill>
+                  <a:srgbClr val="FFFFFF"/>
+                </a:solidFill>
+              </a:defRPr>
+            </a:pPr>
+            <a:r>
+              <a:t>• Mínimo 3 palpites resolvidos para aparecer no ranking</a:t>
+            </a:r>
+          </a:p>
+          <a:p>
+            <a:pPr algn="l">
+              <a:defRPr sz="1600">
+                <a:solidFill>
+                  <a:srgbClr val="FFFFFF"/>
+                </a:solidFill>
+              </a:defRPr>
+            </a:pPr>
+            <a:r>
+              <a:t>• Odds dinâmicas (ex: SIM 3.00x / NÃO 1.50x)</a:t>
+            </a:r>
+          </a:p>
+          <a:p>
+            <a:pPr algn="l">
+              <a:defRPr sz="1600">
+                <a:solidFill>
+                  <a:srgbClr val="FFFFFF"/>
+                </a:solidFill>
+              </a:defRPr>
+            </a:pPr>
+            <a:r>
+              <a:t>• Trending Feed: eventos em alta (+Z$ / 2h)</a:t>
             </a:r>
           </a:p>
         </p:txBody>
       </p:sp>
     </p:spTree>
+    <p:extLst>
+      <p:ext uri="{BB962C8B-B14F-4D97-AF65-F5344CB8AC3E}">
+        <p14:creationId xmlns:p14="http://schemas.microsoft.com/office/powerpoint/2010/main" val="4010129754"/>
+      </p:ext>
+    </p:extLst>
   </p:cSld>
   <p:clrMapOvr>
     <a:masterClrMapping/>
@@ -6935,7 +8012,7 @@
               </a:defRPr>
             </a:pPr>
             <a:r>
-              <a:t>Zafe Privadas (Bolão entre Amigos)</a:t>
+              <a:t>Concurso Mensal (Sobreposto à Liga)</a:t>
             </a:r>
           </a:p>
         </p:txBody>
@@ -7005,7 +8082,7 @@
               </a:defRPr>
             </a:pPr>
             <a:r>
-              <a:t>• Criação: Um usuário desafia outro(s) para um palpite</a:t>
+              <a:t>• Inscrição: Gratuita (fase beta)</a:t>
             </a:r>
           </a:p>
           <a:p>
@@ -7017,7 +8094,7 @@
               </a:defRPr>
             </a:pPr>
             <a:r>
-              <a:t>• Mercado: Fechado (participantes definidos na criação)</a:t>
+              <a:t>• Moeda: ZC$ (moeda virtual do concurso, sem valor real)</a:t>
             </a:r>
           </a:p>
           <a:p>
@@ -7029,7 +8106,7 @@
               </a:defRPr>
             </a:pPr>
             <a:r>
-              <a:t>• Moeda: Z$ Virtual (não convertível em dinheiro real)</a:t>
+              <a:t>• Critério: Quem terminar o mês com mais ZC$ ganha</a:t>
             </a:r>
           </a:p>
           <a:p>
@@ -7041,7 +8118,7 @@
               </a:defRPr>
             </a:pPr>
             <a:r>
-              <a:t>• Resolução: Supermaioria 67% + Sistema de Juízes</a:t>
+              <a:t>• Requisito: 30+ palpites no mês para concorrer</a:t>
             </a:r>
           </a:p>
           <a:p>
@@ -7053,7 +8130,7 @@
               </a:defRPr>
             </a:pPr>
             <a:r>
-              <a:t>• Futuro: Converter Z$ em descontos reais via parcerias</a:t>
+              <a:t>• Prêmio: R$ 500 totais distribuídos via PIX</a:t>
             </a:r>
           </a:p>
         </p:txBody>
@@ -7066,8 +8143,8 @@
         </p:nvSpPr>
         <p:spPr>
           <a:xfrm>
-            <a:off x="6400800" y="1828800"/>
-            <a:ext cx="4572000" cy="457200"/>
+            <a:off x="914400" y="4754880"/>
+            <a:ext cx="4572000" cy="365760"/>
           </a:xfrm>
           <a:prstGeom prst="rect">
             <a:avLst/>
@@ -7081,14 +8158,14 @@
           <a:lstStyle/>
           <a:p>
             <a:pPr algn="l">
-              <a:defRPr sz="2400" b="1">
-                <a:solidFill>
-                  <a:srgbClr val="EF4444"/>
-                </a:solidFill>
-              </a:defRPr>
-            </a:pPr>
-            <a:r>
-              <a:t>4 Travas Legais (Obrigatórias)</a:t>
+              <a:defRPr sz="1800" b="1">
+                <a:solidFill>
+                  <a:srgbClr val="86EFAC"/>
+                </a:solidFill>
+              </a:defRPr>
+            </a:pPr>
+            <a:r>
+              <a:t>Distribuição de Prêmios:</a:t>
             </a:r>
           </a:p>
         </p:txBody>
@@ -7101,8 +8178,8 @@
         </p:nvSpPr>
         <p:spPr>
           <a:xfrm>
-            <a:off x="6400800" y="2377440"/>
-            <a:ext cx="5029200" cy="1828800"/>
+            <a:off x="914400" y="5120640"/>
+            <a:ext cx="5029200" cy="914400"/>
           </a:xfrm>
           <a:prstGeom prst="rect">
             <a:avLst/>
@@ -7116,50 +8193,26 @@
           <a:lstStyle/>
           <a:p>
             <a:pPr algn="l">
-              <a:defRPr sz="1600">
-                <a:solidFill>
-                  <a:srgbClr val="FFFFFF"/>
-                </a:solidFill>
-              </a:defRPr>
-            </a:pPr>
-            <a:r>
-              <a:t>1. Apenas amigos confirmados (24h após aceite mútuo)</a:t>
-            </a:r>
-          </a:p>
-          <a:p>
-            <a:pPr algn="l">
-              <a:defRPr sz="1600">
-                <a:solidFill>
-                  <a:srgbClr val="FFFFFF"/>
-                </a:solidFill>
-              </a:defRPr>
-            </a:pPr>
-            <a:r>
-              <a:t>2. Mercado fechado (sem novos participantes após criação)</a:t>
-            </a:r>
-          </a:p>
-          <a:p>
-            <a:pPr algn="l">
-              <a:defRPr sz="1600">
-                <a:solidFill>
-                  <a:srgbClr val="FFFFFF"/>
-                </a:solidFill>
-              </a:defRPr>
-            </a:pPr>
-            <a:r>
-              <a:t>3. Sem revenda de posição (sem mercado secundário)</a:t>
-            </a:r>
-          </a:p>
-          <a:p>
-            <a:pPr algn="l">
-              <a:defRPr sz="1600">
-                <a:solidFill>
-                  <a:srgbClr val="FFFFFF"/>
-                </a:solidFill>
-              </a:defRPr>
-            </a:pPr>
-            <a:r>
-              <a:t>4. Limite: 5.000 Z$/ano por par de usuários</a:t>
+              <a:defRPr sz="1400">
+                <a:solidFill>
+                  <a:srgbClr val="C8C8C8"/>
+                </a:solidFill>
+              </a:defRPr>
+            </a:pPr>
+            <a:r>
+              <a:t>1º lugar: R$ 200 | 2º lugar: R$ 150 | 3º lugar: R$ 100</a:t>
+            </a:r>
+          </a:p>
+          <a:p>
+            <a:pPr algn="l">
+              <a:defRPr sz="1400">
+                <a:solidFill>
+                  <a:srgbClr val="C8C8C8"/>
+                </a:solidFill>
+              </a:defRPr>
+            </a:pPr>
+            <a:r>
+              <a:t>4º a 5º lugar: R$ 25 cada</a:t>
             </a:r>
           </a:p>
         </p:txBody>
@@ -7172,8 +8225,8 @@
         </p:nvSpPr>
         <p:spPr>
           <a:xfrm>
-            <a:off x="6400800" y="4389120"/>
-            <a:ext cx="5029200" cy="914400"/>
+            <a:off x="6400800" y="1828800"/>
+            <a:ext cx="4572000" cy="457200"/>
           </a:xfrm>
           <a:prstGeom prst="rect">
             <a:avLst/>
@@ -7187,19 +8240,164 @@
           <a:lstStyle/>
           <a:p>
             <a:pPr algn="l">
+              <a:defRPr sz="2400" b="1">
+                <a:solidFill>
+                  <a:srgbClr val="86EFAC"/>
+                </a:solidFill>
+              </a:defRPr>
+            </a:pPr>
+            <a:r>
+              <a:t>Base Legal (Lei 5.768/71)</a:t>
+            </a:r>
+          </a:p>
+        </p:txBody>
+      </p:sp>
+      <p:sp>
+        <p:nvSpPr>
+          <p:cNvPr id="8" name="TextBox 7"/>
+          <p:cNvSpPr txBox="1"/>
+          <p:nvPr/>
+        </p:nvSpPr>
+        <p:spPr>
+          <a:xfrm>
+            <a:off x="6400800" y="2377440"/>
+            <a:ext cx="5029200" cy="731520"/>
+          </a:xfrm>
+          <a:prstGeom prst="rect">
+            <a:avLst/>
+          </a:prstGeom>
+          <a:noFill/>
+        </p:spPr>
+        <p:txBody>
+          <a:bodyPr wrap="square">
+            <a:spAutoFit/>
+          </a:bodyPr>
+          <a:lstStyle/>
+          <a:p>
+            <a:pPr algn="l">
               <a:defRPr sz="1400" b="0">
                 <a:solidFill>
+                  <a:srgbClr val="FFFFFF"/>
+                </a:solidFill>
+              </a:defRPr>
+            </a:pPr>
+            <a:r>
+              <a:t>Art. 1º: Concurso de previsões exige autorização SECAP apenas se prêmios &gt; 10% do valor arrecadado.</a:t>
+            </a:r>
+          </a:p>
+        </p:txBody>
+      </p:sp>
+      <p:sp>
+        <p:nvSpPr>
+          <p:cNvPr id="9" name="TextBox 8"/>
+          <p:cNvSpPr txBox="1"/>
+          <p:nvPr/>
+        </p:nvSpPr>
+        <p:spPr>
+          <a:xfrm>
+            <a:off x="6400800" y="3200400"/>
+            <a:ext cx="4572000" cy="365760"/>
+          </a:xfrm>
+          <a:prstGeom prst="rect">
+            <a:avLst/>
+          </a:prstGeom>
+          <a:noFill/>
+        </p:spPr>
+        <p:txBody>
+          <a:bodyPr wrap="square">
+            <a:spAutoFit/>
+          </a:bodyPr>
+          <a:lstStyle/>
+          <a:p>
+            <a:pPr algn="l">
+              <a:defRPr sz="1800" b="1">
+                <a:solidFill>
+                  <a:srgbClr val="86EFAC"/>
+                </a:solidFill>
+              </a:defRPr>
+            </a:pPr>
+            <a:r>
+              <a:t>Dispensa SECAP</a:t>
+            </a:r>
+          </a:p>
+        </p:txBody>
+      </p:sp>
+      <p:sp>
+        <p:nvSpPr>
+          <p:cNvPr id="10" name="TextBox 9"/>
+          <p:cNvSpPr txBox="1"/>
+          <p:nvPr/>
+        </p:nvSpPr>
+        <p:spPr>
+          <a:xfrm>
+            <a:off x="6400800" y="3657600"/>
+            <a:ext cx="5029200" cy="914400"/>
+          </a:xfrm>
+          <a:prstGeom prst="rect">
+            <a:avLst/>
+          </a:prstGeom>
+          <a:noFill/>
+        </p:spPr>
+        <p:txBody>
+          <a:bodyPr wrap="square">
+            <a:spAutoFit/>
+          </a:bodyPr>
+          <a:lstStyle/>
+          <a:p>
+            <a:pPr algn="l">
+              <a:defRPr sz="1400" b="0">
+                <a:solidFill>
+                  <a:srgbClr val="FFFFFF"/>
+                </a:solidFill>
+              </a:defRPr>
+            </a:pPr>
+            <a:r>
+              <a:t>Concurso regular (R$ 500) tem patrocínio que cobre prêmios. Não há arrecadação líquida da Zafe, dispensando autorização.</a:t>
+            </a:r>
+          </a:p>
+        </p:txBody>
+      </p:sp>
+      <p:sp>
+        <p:nvSpPr>
+          <p:cNvPr id="11" name="TextBox 10"/>
+          <p:cNvSpPr txBox="1"/>
+          <p:nvPr/>
+        </p:nvSpPr>
+        <p:spPr>
+          <a:xfrm>
+            <a:off x="6400800" y="4754880"/>
+            <a:ext cx="5029200" cy="914400"/>
+          </a:xfrm>
+          <a:prstGeom prst="rect">
+            <a:avLst/>
+          </a:prstGeom>
+          <a:noFill/>
+        </p:spPr>
+        <p:txBody>
+          <a:bodyPr wrap="square">
+            <a:spAutoFit/>
+          </a:bodyPr>
+          <a:lstStyle/>
+          <a:p>
+            <a:pPr algn="l">
+              <a:defRPr sz="1400" b="0">
+                <a:solidFill>
                   <a:srgbClr val="EAB308"/>
                 </a:solidFill>
               </a:defRPr>
             </a:pPr>
             <a:r>
-              <a:t>Sistema de Juízes: Se divergência na supermaioria (67%), ativa-se juízes imparciais para decidir.</a:t>
+              <a:t>Concurso Major: Trimestral R$ 10k-25k. Exige processo formal na SECAP, custo de 10% pago pelo patrocinador.</a:t>
             </a:r>
           </a:p>
         </p:txBody>
       </p:sp>
     </p:spTree>
+    <p:extLst>
+      <p:ext uri="{BB962C8B-B14F-4D97-AF65-F5344CB8AC3E}">
+        <p14:creationId xmlns:p14="http://schemas.microsoft.com/office/powerpoint/2010/main" val="2845078262"/>
+      </p:ext>
+    </p:extLst>
   </p:cSld>
   <p:clrMapOvr>
     <a:masterClrMapping/>
@@ -7262,7 +8460,7 @@
               </a:defRPr>
             </a:pPr>
             <a:r>
-              <a:t>Como o Código Sabe quem Ganhou</a:t>
+              <a:t>Zafe Privadas (Bolão entre Amigos)</a:t>
             </a:r>
           </a:p>
         </p:txBody>
@@ -7276,7 +8474,7 @@
         <p:spPr>
           <a:xfrm>
             <a:off x="914400" y="1828800"/>
-            <a:ext cx="2286000" cy="457200"/>
+            <a:ext cx="4572000" cy="457200"/>
           </a:xfrm>
           <a:prstGeom prst="rect">
             <a:avLst/>
@@ -7290,14 +8488,14 @@
           <a:lstStyle/>
           <a:p>
             <a:pPr algn="l">
-              <a:defRPr sz="1800" b="1">
+              <a:defRPr sz="2400" b="1">
                 <a:solidFill>
                   <a:srgbClr val="86EFAC"/>
                 </a:solidFill>
               </a:defRPr>
             </a:pPr>
             <a:r>
-              <a:t>Camada 1: API Fixa</a:t>
+              <a:t>Como Funciona</a:t>
             </a:r>
           </a:p>
         </p:txBody>
@@ -7311,7 +8509,7 @@
         <p:spPr>
           <a:xfrm>
             <a:off x="914400" y="2377440"/>
-            <a:ext cx="2286000" cy="1371600"/>
+            <a:ext cx="5029200" cy="2286000"/>
           </a:xfrm>
           <a:prstGeom prst="rect">
             <a:avLst/>
@@ -7325,26 +8523,62 @@
           <a:lstStyle/>
           <a:p>
             <a:pPr algn="l">
-              <a:defRPr sz="1400" b="0">
-                <a:solidFill>
-                  <a:srgbClr val="FFFFFF"/>
-                </a:solidFill>
-              </a:defRPr>
-            </a:pPr>
-            <a:r>
-              <a:t>Banco Central</a:t>
-            </a:r>
-            <a:br/>
-            <a:r>
-              <a:t>Yahoo Finance</a:t>
-            </a:r>
-            <a:br/>
-            <a:r>
-              <a:t>CoinGecko</a:t>
-            </a:r>
-            <a:br/>
-            <a:r>
-              <a:t>TSE, APIs Esportivas</a:t>
+              <a:defRPr sz="1600">
+                <a:solidFill>
+                  <a:srgbClr val="FFFFFF"/>
+                </a:solidFill>
+              </a:defRPr>
+            </a:pPr>
+            <a:r>
+              <a:t>• Criação: Um usuário desafia outro(s) para um palpite</a:t>
+            </a:r>
+          </a:p>
+          <a:p>
+            <a:pPr algn="l">
+              <a:defRPr sz="1600">
+                <a:solidFill>
+                  <a:srgbClr val="FFFFFF"/>
+                </a:solidFill>
+              </a:defRPr>
+            </a:pPr>
+            <a:r>
+              <a:t>• Mercado: Fechado (participantes definidos na criação)</a:t>
+            </a:r>
+          </a:p>
+          <a:p>
+            <a:pPr algn="l">
+              <a:defRPr sz="1600">
+                <a:solidFill>
+                  <a:srgbClr val="FFFFFF"/>
+                </a:solidFill>
+              </a:defRPr>
+            </a:pPr>
+            <a:r>
+              <a:t>• Moeda: Z$ Virtual (não convertível em dinheiro real)</a:t>
+            </a:r>
+          </a:p>
+          <a:p>
+            <a:pPr algn="l">
+              <a:defRPr sz="1600">
+                <a:solidFill>
+                  <a:srgbClr val="FFFFFF"/>
+                </a:solidFill>
+              </a:defRPr>
+            </a:pPr>
+            <a:r>
+              <a:t>• Resolução: Supermaioria 67% + Sistema de Juízes</a:t>
+            </a:r>
+          </a:p>
+          <a:p>
+            <a:pPr algn="l">
+              <a:defRPr sz="1600">
+                <a:solidFill>
+                  <a:srgbClr val="FFFFFF"/>
+                </a:solidFill>
+              </a:defRPr>
+            </a:pPr>
+            <a:r>
+              <a:t>• Futuro: Converter Z$ em descontos reais via parcerias</a:t>
             </a:r>
           </a:p>
         </p:txBody>
@@ -7357,8 +8591,8 @@
         </p:nvSpPr>
         <p:spPr>
           <a:xfrm>
-            <a:off x="3657600" y="1828800"/>
-            <a:ext cx="2286000" cy="457200"/>
+            <a:off x="6400800" y="1828800"/>
+            <a:ext cx="4572000" cy="457200"/>
           </a:xfrm>
           <a:prstGeom prst="rect">
             <a:avLst/>
@@ -7372,14 +8606,14 @@
           <a:lstStyle/>
           <a:p>
             <a:pPr algn="l">
-              <a:defRPr sz="1800" b="1">
-                <a:solidFill>
-                  <a:srgbClr val="86EFAC"/>
-                </a:solidFill>
-              </a:defRPr>
-            </a:pPr>
-            <a:r>
-              <a:t>Camada 2: IA com Dupla Verificação</a:t>
+              <a:defRPr sz="2400" b="1">
+                <a:solidFill>
+                  <a:srgbClr val="EF4444"/>
+                </a:solidFill>
+              </a:defRPr>
+            </a:pPr>
+            <a:r>
+              <a:t>4 Travas Legais (Obrigatórias)</a:t>
             </a:r>
           </a:p>
         </p:txBody>
@@ -7392,8 +8626,8 @@
         </p:nvSpPr>
         <p:spPr>
           <a:xfrm>
-            <a:off x="3657600" y="2377440"/>
-            <a:ext cx="2286000" cy="1371600"/>
+            <a:off x="6400800" y="2377440"/>
+            <a:ext cx="5029200" cy="1828800"/>
           </a:xfrm>
           <a:prstGeom prst="rect">
             <a:avLst/>
@@ -7407,26 +8641,50 @@
           <a:lstStyle/>
           <a:p>
             <a:pPr algn="l">
-              <a:defRPr sz="1400" b="0">
-                <a:solidFill>
-                  <a:srgbClr val="FFFFFF"/>
-                </a:solidFill>
-              </a:defRPr>
-            </a:pPr>
-            <a:r>
-              <a:t>2 checks independentes</a:t>
-            </a:r>
-            <a:br/>
-            <a:r>
-              <a:t>Web Search</a:t>
-            </a:r>
-            <a:br/>
-            <a:r>
-              <a:t>Confiança ≥ 85%</a:t>
-            </a:r>
-            <a:br/>
-            <a:r>
-              <a:t>Ambos concordam</a:t>
+              <a:defRPr sz="1600">
+                <a:solidFill>
+                  <a:srgbClr val="FFFFFF"/>
+                </a:solidFill>
+              </a:defRPr>
+            </a:pPr>
+            <a:r>
+              <a:t>1. Apenas amigos confirmados (24h após aceite mútuo)</a:t>
+            </a:r>
+          </a:p>
+          <a:p>
+            <a:pPr algn="l">
+              <a:defRPr sz="1600">
+                <a:solidFill>
+                  <a:srgbClr val="FFFFFF"/>
+                </a:solidFill>
+              </a:defRPr>
+            </a:pPr>
+            <a:r>
+              <a:t>2. Mercado fechado (sem novos participantes após criação)</a:t>
+            </a:r>
+          </a:p>
+          <a:p>
+            <a:pPr algn="l">
+              <a:defRPr sz="1600">
+                <a:solidFill>
+                  <a:srgbClr val="FFFFFF"/>
+                </a:solidFill>
+              </a:defRPr>
+            </a:pPr>
+            <a:r>
+              <a:t>3. Sem revenda de posição (sem mercado secundário)</a:t>
+            </a:r>
+          </a:p>
+          <a:p>
+            <a:pPr algn="l">
+              <a:defRPr sz="1600">
+                <a:solidFill>
+                  <a:srgbClr val="FFFFFF"/>
+                </a:solidFill>
+              </a:defRPr>
+            </a:pPr>
+            <a:r>
+              <a:t>4. Limite: 5.000 Z$/ano por par de usuários</a:t>
             </a:r>
           </a:p>
         </p:txBody>
@@ -7439,8 +8697,8 @@
         </p:nvSpPr>
         <p:spPr>
           <a:xfrm>
-            <a:off x="6400800" y="1828800"/>
-            <a:ext cx="2286000" cy="457200"/>
+            <a:off x="6400800" y="4389120"/>
+            <a:ext cx="5029200" cy="914400"/>
           </a:xfrm>
           <a:prstGeom prst="rect">
             <a:avLst/>
@@ -7454,178 +8712,14 @@
           <a:lstStyle/>
           <a:p>
             <a:pPr algn="l">
-              <a:defRPr sz="1800" b="1">
-                <a:solidFill>
-                  <a:srgbClr val="86EFAC"/>
-                </a:solidFill>
-              </a:defRPr>
-            </a:pPr>
-            <a:r>
-              <a:t>Camada 3: Retry Automático</a:t>
-            </a:r>
-          </a:p>
-        </p:txBody>
-      </p:sp>
-      <p:sp>
-        <p:nvSpPr>
-          <p:cNvPr id="8" name="TextBox 7"/>
-          <p:cNvSpPr txBox="1"/>
-          <p:nvPr/>
-        </p:nvSpPr>
-        <p:spPr>
-          <a:xfrm>
-            <a:off x="6400800" y="2377440"/>
-            <a:ext cx="2286000" cy="1371600"/>
-          </a:xfrm>
-          <a:prstGeom prst="rect">
-            <a:avLst/>
-          </a:prstGeom>
-          <a:noFill/>
-        </p:spPr>
-        <p:txBody>
-          <a:bodyPr wrap="square">
-            <a:spAutoFit/>
-          </a:bodyPr>
-          <a:lstStyle/>
-          <a:p>
-            <a:pPr algn="l">
               <a:defRPr sz="1400" b="0">
                 <a:solidFill>
-                  <a:srgbClr val="FFFFFF"/>
-                </a:solidFill>
-              </a:defRPr>
-            </a:pPr>
-            <a:r>
-              <a:t>Falhou?</a:t>
-            </a:r>
-            <a:br/>
-            <a:r>
-              <a:t>Tenta novamente</a:t>
-            </a:r>
-            <a:br/>
-            <a:r>
-              <a:t>a cada 2h</a:t>
-            </a:r>
-            <a:br/>
-            <a:r>
-              <a:t>(máximo 3x)</a:t>
-            </a:r>
-          </a:p>
-        </p:txBody>
-      </p:sp>
-      <p:sp>
-        <p:nvSpPr>
-          <p:cNvPr id="9" name="TextBox 8"/>
-          <p:cNvSpPr txBox="1"/>
-          <p:nvPr/>
-        </p:nvSpPr>
-        <p:spPr>
-          <a:xfrm>
-            <a:off x="9144000" y="1828800"/>
-            <a:ext cx="2286000" cy="457200"/>
-          </a:xfrm>
-          <a:prstGeom prst="rect">
-            <a:avLst/>
-          </a:prstGeom>
-          <a:noFill/>
-        </p:spPr>
-        <p:txBody>
-          <a:bodyPr wrap="square">
-            <a:spAutoFit/>
-          </a:bodyPr>
-          <a:lstStyle/>
-          <a:p>
-            <a:pPr algn="l">
-              <a:defRPr sz="1800" b="1">
-                <a:solidFill>
-                  <a:srgbClr val="EF4444"/>
-                </a:solidFill>
-              </a:defRPr>
-            </a:pPr>
-            <a:r>
-              <a:t>Camada 4: Reembolso</a:t>
-            </a:r>
-          </a:p>
-        </p:txBody>
-      </p:sp>
-      <p:sp>
-        <p:nvSpPr>
-          <p:cNvPr id="10" name="TextBox 9"/>
-          <p:cNvSpPr txBox="1"/>
-          <p:nvPr/>
-        </p:nvSpPr>
-        <p:spPr>
-          <a:xfrm>
-            <a:off x="9144000" y="2377440"/>
-            <a:ext cx="2286000" cy="1371600"/>
-          </a:xfrm>
-          <a:prstGeom prst="rect">
-            <a:avLst/>
-          </a:prstGeom>
-          <a:noFill/>
-        </p:spPr>
-        <p:txBody>
-          <a:bodyPr wrap="square">
-            <a:spAutoFit/>
-          </a:bodyPr>
-          <a:lstStyle/>
-          <a:p>
-            <a:pPr algn="l">
-              <a:defRPr sz="1400" b="0">
-                <a:solidFill>
-                  <a:srgbClr val="FFFFFF"/>
-                </a:solidFill>
-              </a:defRPr>
-            </a:pPr>
-            <a:r>
-              <a:t>Ninguém perde</a:t>
-            </a:r>
-            <a:br/>
-            <a:r>
-              <a:t>se não resolver</a:t>
-            </a:r>
-            <a:br/>
-            <a:r>
-              <a:t>Todos recebem Z$</a:t>
-            </a:r>
-            <a:br/>
-            <a:r>
-              <a:t>de volta</a:t>
-            </a:r>
-          </a:p>
-        </p:txBody>
-      </p:sp>
-      <p:sp>
-        <p:nvSpPr>
-          <p:cNvPr id="11" name="TextBox 10"/>
-          <p:cNvSpPr txBox="1"/>
-          <p:nvPr/>
-        </p:nvSpPr>
-        <p:spPr>
-          <a:xfrm>
-            <a:off x="914400" y="5486400"/>
-            <a:ext cx="10058400" cy="548640"/>
-          </a:xfrm>
-          <a:prstGeom prst="rect">
-            <a:avLst/>
-          </a:prstGeom>
-          <a:noFill/>
-        </p:spPr>
-        <p:txBody>
-          <a:bodyPr wrap="square">
-            <a:spAutoFit/>
-          </a:bodyPr>
-          <a:lstStyle/>
-          <a:p>
-            <a:pPr algn="ctr">
-              <a:defRPr sz="1800" b="1">
-                <a:solidFill>
-                  <a:srgbClr val="86EFAC"/>
-                </a:solidFill>
-              </a:defRPr>
-            </a:pPr>
-            <a:r>
-              <a:t>Taxa de resolução automática: 87% | Reembolso: 5% (eventos subjetivos sem fontes claras)</a:t>
+                  <a:srgbClr val="EAB308"/>
+                </a:solidFill>
+              </a:defRPr>
+            </a:pPr>
+            <a:r>
+              <a:t>Sistema de Juízes: Se divergência na supermaioria (67%), ativa-se juízes imparciais para decidir.</a:t>
             </a:r>
           </a:p>
         </p:txBody>
@@ -7693,7 +8787,7 @@
               </a:defRPr>
             </a:pPr>
             <a:r>
-              <a:t>Estado Atual (Maio/2026)</a:t>
+              <a:t>Como o Código Sabe quem Ganhou</a:t>
             </a:r>
           </a:p>
         </p:txBody>
@@ -7707,7 +8801,7 @@
         <p:spPr>
           <a:xfrm>
             <a:off x="914400" y="1828800"/>
-            <a:ext cx="4572000" cy="457200"/>
+            <a:ext cx="2286000" cy="457200"/>
           </a:xfrm>
           <a:prstGeom prst="rect">
             <a:avLst/>
@@ -7721,14 +8815,14 @@
           <a:lstStyle/>
           <a:p>
             <a:pPr algn="l">
-              <a:defRPr sz="2400" b="1">
+              <a:defRPr sz="1800" b="1">
                 <a:solidFill>
                   <a:srgbClr val="86EFAC"/>
                 </a:solidFill>
               </a:defRPr>
             </a:pPr>
             <a:r>
-              <a:t>O que somos hoje</a:t>
+              <a:t>Camada 1: API Fixa</a:t>
             </a:r>
           </a:p>
         </p:txBody>
@@ -7742,7 +8836,7 @@
         <p:spPr>
           <a:xfrm>
             <a:off x="914400" y="2377440"/>
-            <a:ext cx="5029200" cy="1371600"/>
+            <a:ext cx="2286000" cy="1371600"/>
           </a:xfrm>
           <a:prstGeom prst="rect">
             <a:avLst/>
@@ -7756,38 +8850,26 @@
           <a:lstStyle/>
           <a:p>
             <a:pPr algn="l">
-              <a:defRPr sz="1600">
-                <a:solidFill>
-                  <a:srgbClr val="FFFFFF"/>
-                </a:solidFill>
-              </a:defRPr>
-            </a:pPr>
-            <a:r>
-              <a:t>• Lançamos utilizando Zafes como moeda virtual</a:t>
-            </a:r>
-          </a:p>
-          <a:p>
-            <a:pPr algn="l">
-              <a:defRPr sz="1600">
-                <a:solidFill>
-                  <a:srgbClr val="FFFFFF"/>
-                </a:solidFill>
-              </a:defRPr>
-            </a:pPr>
-            <a:r>
-              <a:t>• Sistema de resolução em 4 camadas (87% sucesso)</a:t>
-            </a:r>
-          </a:p>
-          <a:p>
-            <a:pPr algn="l">
-              <a:defRPr sz="1600">
-                <a:solidFill>
-                  <a:srgbClr val="FFFFFF"/>
-                </a:solidFill>
-              </a:defRPr>
-            </a:pPr>
-            <a:r>
-              <a:t>• Eventos reais rodando na Liga e Econômico</a:t>
+              <a:defRPr sz="1400" b="0">
+                <a:solidFill>
+                  <a:srgbClr val="FFFFFF"/>
+                </a:solidFill>
+              </a:defRPr>
+            </a:pPr>
+            <a:r>
+              <a:t>Banco Central</a:t>
+            </a:r>
+            <a:br/>
+            <a:r>
+              <a:t>Yahoo Finance</a:t>
+            </a:r>
+            <a:br/>
+            <a:r>
+              <a:t>CoinGecko</a:t>
+            </a:r>
+            <a:br/>
+            <a:r>
+              <a:t>TSE, APIs Esportivas</a:t>
             </a:r>
           </a:p>
         </p:txBody>
@@ -7800,8 +8882,8 @@
         </p:nvSpPr>
         <p:spPr>
           <a:xfrm>
-            <a:off x="914400" y="3840480"/>
-            <a:ext cx="5029200" cy="548640"/>
+            <a:off x="3657600" y="1828800"/>
+            <a:ext cx="2286000" cy="457200"/>
           </a:xfrm>
           <a:prstGeom prst="rect">
             <a:avLst/>
@@ -7815,14 +8897,14 @@
           <a:lstStyle/>
           <a:p>
             <a:pPr algn="l">
-              <a:defRPr sz="1600" b="1">
-                <a:solidFill>
-                  <a:srgbClr val="EAB308"/>
-                </a:solidFill>
-              </a:defRPr>
-            </a:pPr>
-            <a:r>
-              <a:t>Objetivo Imediato: Alcançar 1.000 usuários ativos na fase de testes.</a:t>
+              <a:defRPr sz="1800" b="1">
+                <a:solidFill>
+                  <a:srgbClr val="86EFAC"/>
+                </a:solidFill>
+              </a:defRPr>
+            </a:pPr>
+            <a:r>
+              <a:t>Camada 2: IA com Dupla Verificação</a:t>
             </a:r>
           </a:p>
         </p:txBody>
@@ -7835,8 +8917,8 @@
         </p:nvSpPr>
         <p:spPr>
           <a:xfrm>
-            <a:off x="6400800" y="1828800"/>
-            <a:ext cx="4572000" cy="457200"/>
+            <a:off x="3657600" y="2377440"/>
+            <a:ext cx="2286000" cy="1371600"/>
           </a:xfrm>
           <a:prstGeom prst="rect">
             <a:avLst/>
@@ -7850,14 +8932,26 @@
           <a:lstStyle/>
           <a:p>
             <a:pPr algn="l">
-              <a:defRPr sz="2400" b="1">
-                <a:solidFill>
-                  <a:srgbClr val="86EFAC"/>
-                </a:solidFill>
-              </a:defRPr>
-            </a:pPr>
-            <a:r>
-              <a:t>O que muda com 1000 usuários</a:t>
+              <a:defRPr sz="1400" b="0">
+                <a:solidFill>
+                  <a:srgbClr val="FFFFFF"/>
+                </a:solidFill>
+              </a:defRPr>
+            </a:pPr>
+            <a:r>
+              <a:t>2 checks independentes</a:t>
+            </a:r>
+            <a:br/>
+            <a:r>
+              <a:t>Web Search</a:t>
+            </a:r>
+            <a:br/>
+            <a:r>
+              <a:t>Confiança ≥ 85%</a:t>
+            </a:r>
+            <a:br/>
+            <a:r>
+              <a:t>Ambos concordam</a:t>
             </a:r>
           </a:p>
         </p:txBody>
@@ -7870,8 +8964,8 @@
         </p:nvSpPr>
         <p:spPr>
           <a:xfrm>
-            <a:off x="6400800" y="2377440"/>
-            <a:ext cx="5029200" cy="1828800"/>
+            <a:off x="6400800" y="1828800"/>
+            <a:ext cx="2286000" cy="457200"/>
           </a:xfrm>
           <a:prstGeom prst="rect">
             <a:avLst/>
@@ -7885,62 +8979,14 @@
           <a:lstStyle/>
           <a:p>
             <a:pPr algn="l">
-              <a:defRPr sz="1600">
-                <a:solidFill>
-                  <a:srgbClr val="FFFFFF"/>
-                </a:solidFill>
-              </a:defRPr>
-            </a:pPr>
-            <a:r>
-              <a:t>• Aumentar volume de palpites na Liga</a:t>
-            </a:r>
-          </a:p>
-          <a:p>
-            <a:pPr algn="l">
-              <a:defRPr sz="1600">
-                <a:solidFill>
-                  <a:srgbClr val="FFFFFF"/>
-                </a:solidFill>
-              </a:defRPr>
-            </a:pPr>
-            <a:r>
-              <a:t>• Validar modelo de competição social</a:t>
-            </a:r>
-          </a:p>
-          <a:p>
-            <a:pPr algn="l">
-              <a:defRPr sz="1600">
-                <a:solidFill>
-                  <a:srgbClr val="FFFFFF"/>
-                </a:solidFill>
-              </a:defRPr>
-            </a:pPr>
-            <a:r>
-              <a:t>• Migrar de beta para lançamento oficial</a:t>
-            </a:r>
-          </a:p>
-          <a:p>
-            <a:pPr algn="l">
-              <a:defRPr sz="1600">
-                <a:solidFill>
-                  <a:srgbClr val="FFFFFF"/>
-                </a:solidFill>
-              </a:defRPr>
-            </a:pPr>
-            <a:r>
-              <a:t>• Primeiro concurso com prêmio real via PIX</a:t>
-            </a:r>
-          </a:p>
-          <a:p>
-            <a:pPr algn="l">
-              <a:defRPr sz="1600">
-                <a:solidFill>
-                  <a:srgbClr val="FFFFFF"/>
-                </a:solidFill>
-              </a:defRPr>
-            </a:pPr>
-            <a:r>
-              <a:t>• Atrair patrocinadores corporativos</a:t>
+              <a:defRPr sz="1800" b="1">
+                <a:solidFill>
+                  <a:srgbClr val="86EFAC"/>
+                </a:solidFill>
+              </a:defRPr>
+            </a:pPr>
+            <a:r>
+              <a:t>Camada 3: Retry Automático</a:t>
             </a:r>
           </a:p>
         </p:txBody>
@@ -7953,8 +8999,8 @@
         </p:nvSpPr>
         <p:spPr>
           <a:xfrm>
-            <a:off x="914400" y="5669280"/>
-            <a:ext cx="10058400" cy="548640"/>
+            <a:off x="6400800" y="2377440"/>
+            <a:ext cx="2286000" cy="1371600"/>
           </a:xfrm>
           <a:prstGeom prst="rect">
             <a:avLst/>
@@ -7967,6 +9013,135 @@
           </a:bodyPr>
           <a:lstStyle/>
           <a:p>
+            <a:pPr algn="l">
+              <a:defRPr sz="1400" b="0">
+                <a:solidFill>
+                  <a:srgbClr val="FFFFFF"/>
+                </a:solidFill>
+              </a:defRPr>
+            </a:pPr>
+            <a:r>
+              <a:t>Falhou?</a:t>
+            </a:r>
+            <a:br/>
+            <a:r>
+              <a:t>Tenta novamente</a:t>
+            </a:r>
+            <a:br/>
+            <a:r>
+              <a:t>a cada 2h</a:t>
+            </a:r>
+            <a:br/>
+            <a:r>
+              <a:t>(máximo 3x)</a:t>
+            </a:r>
+          </a:p>
+        </p:txBody>
+      </p:sp>
+      <p:sp>
+        <p:nvSpPr>
+          <p:cNvPr id="9" name="TextBox 8"/>
+          <p:cNvSpPr txBox="1"/>
+          <p:nvPr/>
+        </p:nvSpPr>
+        <p:spPr>
+          <a:xfrm>
+            <a:off x="9144000" y="1828800"/>
+            <a:ext cx="2286000" cy="457200"/>
+          </a:xfrm>
+          <a:prstGeom prst="rect">
+            <a:avLst/>
+          </a:prstGeom>
+          <a:noFill/>
+        </p:spPr>
+        <p:txBody>
+          <a:bodyPr wrap="square">
+            <a:spAutoFit/>
+          </a:bodyPr>
+          <a:lstStyle/>
+          <a:p>
+            <a:pPr algn="l">
+              <a:defRPr sz="1800" b="1">
+                <a:solidFill>
+                  <a:srgbClr val="EF4444"/>
+                </a:solidFill>
+              </a:defRPr>
+            </a:pPr>
+            <a:r>
+              <a:t>Camada 4: Reembolso</a:t>
+            </a:r>
+          </a:p>
+        </p:txBody>
+      </p:sp>
+      <p:sp>
+        <p:nvSpPr>
+          <p:cNvPr id="10" name="TextBox 9"/>
+          <p:cNvSpPr txBox="1"/>
+          <p:nvPr/>
+        </p:nvSpPr>
+        <p:spPr>
+          <a:xfrm>
+            <a:off x="9144000" y="2377440"/>
+            <a:ext cx="2286000" cy="1371600"/>
+          </a:xfrm>
+          <a:prstGeom prst="rect">
+            <a:avLst/>
+          </a:prstGeom>
+          <a:noFill/>
+        </p:spPr>
+        <p:txBody>
+          <a:bodyPr wrap="square">
+            <a:spAutoFit/>
+          </a:bodyPr>
+          <a:lstStyle/>
+          <a:p>
+            <a:pPr algn="l">
+              <a:defRPr sz="1400" b="0">
+                <a:solidFill>
+                  <a:srgbClr val="FFFFFF"/>
+                </a:solidFill>
+              </a:defRPr>
+            </a:pPr>
+            <a:r>
+              <a:t>Ninguém perde</a:t>
+            </a:r>
+            <a:br/>
+            <a:r>
+              <a:t>se não resolver</a:t>
+            </a:r>
+            <a:br/>
+            <a:r>
+              <a:t>Todos recebem Z$</a:t>
+            </a:r>
+            <a:br/>
+            <a:r>
+              <a:t>de volta</a:t>
+            </a:r>
+          </a:p>
+        </p:txBody>
+      </p:sp>
+      <p:sp>
+        <p:nvSpPr>
+          <p:cNvPr id="11" name="TextBox 10"/>
+          <p:cNvSpPr txBox="1"/>
+          <p:nvPr/>
+        </p:nvSpPr>
+        <p:spPr>
+          <a:xfrm>
+            <a:off x="914400" y="5486400"/>
+            <a:ext cx="10058400" cy="548640"/>
+          </a:xfrm>
+          <a:prstGeom prst="rect">
+            <a:avLst/>
+          </a:prstGeom>
+          <a:noFill/>
+        </p:spPr>
+        <p:txBody>
+          <a:bodyPr wrap="square">
+            <a:spAutoFit/>
+          </a:bodyPr>
+          <a:lstStyle/>
+          <a:p>
             <a:pPr algn="ctr">
               <a:defRPr sz="1800" b="1">
                 <a:solidFill>
@@ -7975,7 +9150,7 @@
               </a:defRPr>
             </a:pPr>
             <a:r>
-              <a:t>Zafes: A moeda virtual que gera prêmios reais através de comprovação de habilidade analítica.</a:t>
+              <a:t>Taxa de resolução automática: 87% | Reembolso: 5% (eventos subjetivos sem fontes claras)</a:t>
             </a:r>
           </a:p>
         </p:txBody>
@@ -8621,4 +9796,26 @@
     </a:ext>
   </a:extLst>
 </a:theme>
+</file>
+
+<file path=ppt/webextensions/taskpanes.xml><?xml version="1.0" encoding="utf-8"?>
+<wetp:taskpanes xmlns:wetp="http://schemas.microsoft.com/office/webextensions/taskpanes/2010/11">
+  <wetp:taskpane dockstate="right" visibility="0" width="350" row="0">
+    <wetp:webextensionref xmlns:r="http://schemas.openxmlformats.org/officeDocument/2006/relationships" r:id="rId1"/>
+  </wetp:taskpane>
+</wetp:taskpanes>
+</file>
+
+<file path=ppt/webextensions/webextension1.xml><?xml version="1.0" encoding="utf-8"?>
+<we:webextension xmlns:we="http://schemas.microsoft.com/office/webextensions/webextension/2010/11" id="{49766D2C-7749-A643-A423-E1A90DF3D1F0}">
+  <we:reference id="wa200010001" version="1.0.0.1" store="en-US" storeType="OMEX"/>
+  <we:alternateReferences>
+    <we:reference id="wa200010001" version="1.0.0.1" store="en-US" storeType="OMEX"/>
+  </we:alternateReferences>
+  <we:properties>
+    <we:property name="claude.fileId" value="&quot;698ae5f5-3c5b-4394-8bd2-631cafcee4b9&quot;"/>
+  </we:properties>
+  <we:bindings/>
+  <we:snapshot xmlns:r="http://schemas.openxmlformats.org/officeDocument/2006/relationships"/>
+</we:webextension>
 </file>
</xml_diff>